<commit_message>
chore: daily sync 2026-09-15
</commit_message>
<xml_diff>
--- a/decks/Balkanea-Supabase-vs-MySQL-Comparison.pptx
+++ b/decks/Balkanea-Supabase-vs-MySQL-Comparison.pptx
@@ -12,6 +12,9 @@
     <p:sldId id="260" r:id="rId11"/>
     <p:sldId id="261" r:id="rId12"/>
     <p:sldId id="262" r:id="rId13"/>
+    <p:sldId id="263" r:id="rId14"/>
+    <p:sldId id="264" r:id="rId15"/>
+    <p:sldId id="265" r:id="rId16"/>
   </p:sldIdLst>
   <p:sldSz cx="12192000" cy="6858000" type="screen4x3"/>
   <p:notesSz cx="6858000" cy="9144000"/>
@@ -143,35 +146,31 @@
           </c:spPr>
           <c:cat>
             <c:strRef>
-              <c:f>Sheet1!$A$2:$A$4</c:f>
+              <c:f>Sheet1!$A$2:$A$3</c:f>
               <c:strCache>
-                <c:ptCount val="3"/>
+                <c:ptCount val="2"/>
                 <c:pt idx="0">
-                  <c:v>Run 1 (cold)</c:v>
+                  <c:v>Range A: Nov 15–18
+(MySQL run 1st)</c:v>
                 </c:pt>
                 <c:pt idx="1">
-                  <c:v>Run 2 (warm)</c:v>
-                </c:pt>
-                <c:pt idx="2">
-                  <c:v>Run 3 (warm)</c:v>
+                  <c:v>Range B: Dec 20–23
+(Supabase run 1st)</c:v>
                 </c:pt>
               </c:strCache>
             </c:strRef>
           </c:cat>
           <c:val>
             <c:numRef>
-              <c:f>Sheet1!$B$2:$B$4</c:f>
+              <c:f>Sheet1!$B$2:$B$3</c:f>
               <c:numCache>
                 <c:formatCode>General</c:formatCode>
-                <c:ptCount val="3"/>
+                <c:ptCount val="2"/>
                 <c:pt idx="0">
-                  <c:v>14.1</c:v>
+                  <c:v>66.9</c:v>
                 </c:pt>
                 <c:pt idx="1">
-                  <c:v>10.4</c:v>
-                </c:pt>
-                <c:pt idx="2">
-                  <c:v>9.9</c:v>
+                  <c:v>76.6</c:v>
                 </c:pt>
               </c:numCache>
             </c:numRef>
@@ -198,35 +197,31 @@
           </c:spPr>
           <c:cat>
             <c:strRef>
-              <c:f>Sheet1!$A$2:$A$4</c:f>
+              <c:f>Sheet1!$A$2:$A$3</c:f>
               <c:strCache>
-                <c:ptCount val="3"/>
+                <c:ptCount val="2"/>
                 <c:pt idx="0">
-                  <c:v>Run 1 (cold)</c:v>
+                  <c:v>Range A: Nov 15–18
+(MySQL run 1st)</c:v>
                 </c:pt>
                 <c:pt idx="1">
-                  <c:v>Run 2 (warm)</c:v>
-                </c:pt>
-                <c:pt idx="2">
-                  <c:v>Run 3 (warm)</c:v>
+                  <c:v>Range B: Dec 20–23
+(Supabase run 1st)</c:v>
                 </c:pt>
               </c:strCache>
             </c:strRef>
           </c:cat>
           <c:val>
             <c:numRef>
-              <c:f>Sheet1!$C$2:$C$4</c:f>
+              <c:f>Sheet1!$C$2:$C$3</c:f>
               <c:numCache>
                 <c:formatCode>General</c:formatCode>
-                <c:ptCount val="3"/>
+                <c:ptCount val="2"/>
                 <c:pt idx="0">
-                  <c:v>17.7</c:v>
+                  <c:v>122.3</c:v>
                 </c:pt>
                 <c:pt idx="1">
-                  <c:v>12.1</c:v>
-                </c:pt>
-                <c:pt idx="2">
-                  <c:v>12.4</c:v>
+                  <c:v>112.3</c:v>
                 </c:pt>
               </c:numCache>
             </c:numRef>
@@ -296,7 +291,7 @@
               <a:p>
                 <a:r>
                   <a:rPr sz="900"/>
-                  <a:t>Total seconds, full search → last chunk</a:t>
+                  <a:t>Total seconds, full search → result count settled</a:t>
                 </a:r>
               </a:p>
             </c:rich>
@@ -316,6 +311,209 @@
             </a:pPr>
           </a:p>
         </c:txPr>
+        <c:crossAx val="-2068027336"/>
+        <c:crosses val="autoZero"/>
+      </c:valAx>
+    </c:plotArea>
+    <c:legend>
+      <c:legendPos val="b"/>
+      <c:overlay val="0"/>
+    </c:legend>
+    <c:dispBlanksAs val="gap"/>
+  </c:chart>
+  <c:txPr>
+    <a:bodyPr/>
+    <a:lstStyle/>
+    <a:p>
+      <a:pPr>
+        <a:defRPr sz="1800"/>
+      </a:pPr>
+      <a:endParaRPr lang="en-US"/>
+    </a:p>
+  </c:txPr>
+  <c:externalData r:id="rId1">
+    <c:autoUpdate val="0"/>
+  </c:externalData>
+</c:chartSpace>
+</file>
+
+<file path=ppt/charts/chart2.xml><?xml version="1.0" encoding="utf-8"?>
+<c:chartSpace xmlns:c="http://schemas.openxmlformats.org/drawingml/2006/chart" xmlns:a="http://schemas.openxmlformats.org/drawingml/2006/main" xmlns:r="http://schemas.openxmlformats.org/officeDocument/2006/relationships">
+  <c:date1904 val="0"/>
+  <c:chart>
+    <c:autoTitleDeleted val="0"/>
+    <c:plotArea>
+      <c:barChart>
+        <c:barDir val="bar"/>
+        <c:grouping val="percentStacked"/>
+        <c:ser>
+          <c:idx val="0"/>
+          <c:order val="0"/>
+          <c:tx>
+            <c:strRef>
+              <c:f>Sheet1!$B$1</c:f>
+              <c:strCache>
+                <c:ptCount val="1"/>
+                <c:pt idx="0">
+                  <c:v>WP nonce refresh</c:v>
+                </c:pt>
+              </c:strCache>
+            </c:strRef>
+          </c:tx>
+          <c:spPr>
+            <a:solidFill>
+              <a:srgbClr val="1C4E80"/>
+            </a:solidFill>
+          </c:spPr>
+          <c:cat>
+            <c:strRef>
+              <c:f>Sheet1!$A$2:$A$2</c:f>
+              <c:strCache>
+                <c:ptCount val="1"/>
+                <c:pt idx="0">
+                  <c:v>Cold Athens search (24.8s total)</c:v>
+                </c:pt>
+              </c:strCache>
+            </c:strRef>
+          </c:cat>
+          <c:val>
+            <c:numRef>
+              <c:f>Sheet1!$B$2:$B$2</c:f>
+              <c:numCache>
+                <c:formatCode>General</c:formatCode>
+                <c:ptCount val="1"/>
+                <c:pt idx="0">
+                  <c:v>33.6</c:v>
+                </c:pt>
+              </c:numCache>
+            </c:numRef>
+          </c:val>
+        </c:ser>
+        <c:ser>
+          <c:idx val="1"/>
+          <c:order val="1"/>
+          <c:tx>
+            <c:strRef>
+              <c:f>Sheet1!$C$1</c:f>
+              <c:strCache>
+                <c:ptCount val="1"/>
+                <c:pt idx="0">
+                  <c:v>RateHawk + content fetch</c:v>
+                </c:pt>
+              </c:strCache>
+            </c:strRef>
+          </c:tx>
+          <c:spPr>
+            <a:solidFill>
+              <a:srgbClr val="E08E1D"/>
+            </a:solidFill>
+          </c:spPr>
+          <c:cat>
+            <c:strRef>
+              <c:f>Sheet1!$A$2:$A$2</c:f>
+              <c:strCache>
+                <c:ptCount val="1"/>
+                <c:pt idx="0">
+                  <c:v>Cold Athens search (24.8s total)</c:v>
+                </c:pt>
+              </c:strCache>
+            </c:strRef>
+          </c:cat>
+          <c:val>
+            <c:numRef>
+              <c:f>Sheet1!$C$2:$C$2</c:f>
+              <c:numCache>
+                <c:formatCode>General</c:formatCode>
+                <c:ptCount val="1"/>
+                <c:pt idx="0">
+                  <c:v>65.5</c:v>
+                </c:pt>
+              </c:numCache>
+            </c:numRef>
+          </c:val>
+        </c:ser>
+        <c:ser>
+          <c:idx val="2"/>
+          <c:order val="2"/>
+          <c:tx>
+            <c:strRef>
+              <c:f>Sheet1!$D$1</c:f>
+              <c:strCache>
+                <c:ptCount val="1"/>
+                <c:pt idx="0">
+                  <c:v>Client render</c:v>
+                </c:pt>
+              </c:strCache>
+            </c:strRef>
+          </c:tx>
+          <c:spPr>
+            <a:solidFill>
+              <a:srgbClr val="1F7A4D"/>
+            </a:solidFill>
+          </c:spPr>
+          <c:cat>
+            <c:strRef>
+              <c:f>Sheet1!$A$2:$A$2</c:f>
+              <c:strCache>
+                <c:ptCount val="1"/>
+                <c:pt idx="0">
+                  <c:v>Cold Athens search (24.8s total)</c:v>
+                </c:pt>
+              </c:strCache>
+            </c:strRef>
+          </c:cat>
+          <c:val>
+            <c:numRef>
+              <c:f>Sheet1!$D$2:$D$2</c:f>
+              <c:numCache>
+                <c:formatCode>General</c:formatCode>
+                <c:ptCount val="1"/>
+                <c:pt idx="0">
+                  <c:v>0.9</c:v>
+                </c:pt>
+              </c:numCache>
+            </c:numRef>
+          </c:val>
+        </c:ser>
+        <c:overlap val="100"/>
+        <c:axId val="-2068027336"/>
+        <c:axId val="-2113994440"/>
+      </c:barChart>
+      <c:catAx>
+        <c:axId val="-2068027336"/>
+        <c:scaling>
+          <c:orientation val="minMax"/>
+        </c:scaling>
+        <c:delete val="0"/>
+        <c:axPos val="l"/>
+        <c:majorTickMark val="out"/>
+        <c:minorTickMark val="none"/>
+        <c:tickLblPos val="nextTo"/>
+        <c:txPr>
+          <a:bodyPr/>
+          <a:lstStyle/>
+          <a:p>
+            <a:pPr>
+              <a:defRPr sz="1000"/>
+            </a:pPr>
+          </a:p>
+        </c:txPr>
+        <c:crossAx val="-2113994440"/>
+        <c:crosses val="autoZero"/>
+        <c:auto val="1"/>
+        <c:lblAlgn val="ctr"/>
+        <c:lblOffset val="100"/>
+        <c:noMultiLvlLbl val="0"/>
+      </c:catAx>
+      <c:valAx>
+        <c:axId val="-2113994440"/>
+        <c:scaling/>
+        <c:delete/>
+        <c:axPos val="b"/>
+        <c:majorGridlines/>
+        <c:majorTickMark val="out"/>
+        <c:minorTickMark val="none"/>
+        <c:tickLblPos val="nextTo"/>
         <c:crossAx val="-2068027336"/>
         <c:crosses val="autoZero"/>
       </c:valAx>
@@ -3525,7 +3723,662 @@
                 </a:solidFill>
                 <a:latin typeface="Segoe UI"/>
               </a:rPr>
-              <a:t>2026-09-14</a:t>
+              <a:t>2026-09-14  •  performance re-run 2026-09-15</a:t>
+            </a:r>
+          </a:p>
+        </p:txBody>
+      </p:sp>
+    </p:spTree>
+  </p:cSld>
+  <p:clrMapOvr>
+    <a:masterClrMapping/>
+  </p:clrMapOvr>
+</p:sld>
+</file>
+
+<file path=ppt/slides/slide10.xml><?xml version="1.0" encoding="utf-8"?>
+<p:sld xmlns:a="http://schemas.openxmlformats.org/drawingml/2006/main" xmlns:p="http://schemas.openxmlformats.org/presentationml/2006/main" xmlns:r="http://schemas.openxmlformats.org/officeDocument/2006/relationships">
+  <p:cSld>
+    <p:bg>
+      <p:bgPr>
+        <a:solidFill>
+          <a:srgbClr val="FAF7F2"/>
+        </a:solidFill>
+        <a:effectLst/>
+      </p:bgPr>
+    </p:bg>
+    <p:spTree>
+      <p:nvGrpSpPr>
+        <p:cNvPr id="1" name=""/>
+        <p:cNvGrpSpPr/>
+        <p:nvPr/>
+      </p:nvGrpSpPr>
+      <p:grpSpPr/>
+      <p:sp>
+        <p:nvSpPr>
+          <p:cNvPr id="2" name="TextBox 1"/>
+          <p:cNvSpPr txBox="1"/>
+          <p:nvPr/>
+        </p:nvSpPr>
+        <p:spPr>
+          <a:xfrm>
+            <a:off x="502920" y="560000"/>
+            <a:ext cx="11185855" cy="300000"/>
+          </a:xfrm>
+          <a:prstGeom prst="rect">
+            <a:avLst/>
+          </a:prstGeom>
+          <a:noFill/>
+        </p:spPr>
+        <p:txBody>
+          <a:bodyPr wrap="square" anchor="t" lIns="0" rIns="0" tIns="0" bIns="0">
+            <a:spAutoFit/>
+          </a:bodyPr>
+          <a:lstStyle/>
+          <a:p>
+            <a:pPr algn="l"/>
+            <a:r>
+              <a:rPr sz="1300" b="1">
+                <a:solidFill>
+                  <a:srgbClr val="7A3E0F"/>
+                </a:solidFill>
+                <a:latin typeface="Segoe UI Semibold"/>
+              </a:rPr>
+              <a:t>09  —  NEXT STEPS</a:t>
+            </a:r>
+          </a:p>
+        </p:txBody>
+      </p:sp>
+      <p:sp>
+        <p:nvSpPr>
+          <p:cNvPr id="3" name="TextBox 2"/>
+          <p:cNvSpPr txBox="1"/>
+          <p:nvPr/>
+        </p:nvSpPr>
+        <p:spPr>
+          <a:xfrm>
+            <a:off x="502920" y="880000"/>
+            <a:ext cx="11185855" cy="500000"/>
+          </a:xfrm>
+          <a:prstGeom prst="rect">
+            <a:avLst/>
+          </a:prstGeom>
+          <a:noFill/>
+        </p:spPr>
+        <p:txBody>
+          <a:bodyPr wrap="square" anchor="t" lIns="0" rIns="0" tIns="0" bIns="0">
+            <a:spAutoFit/>
+          </a:bodyPr>
+          <a:lstStyle/>
+          <a:p>
+            <a:pPr algn="l"/>
+            <a:r>
+              <a:rPr sz="2400" b="1">
+                <a:solidFill>
+                  <a:srgbClr val="1A1A2E"/>
+                </a:solidFill>
+                <a:latin typeface="Segoe UI Semibold"/>
+              </a:rPr>
+              <a:t>Open items and where this goes next</a:t>
+            </a:r>
+          </a:p>
+        </p:txBody>
+      </p:sp>
+      <p:sp>
+        <p:nvSpPr>
+          <p:cNvPr id="4" name="Rounded Rectangle 3"/>
+          <p:cNvSpPr/>
+          <p:nvPr/>
+        </p:nvSpPr>
+        <p:spPr>
+          <a:xfrm>
+            <a:off x="502920" y="1560000"/>
+            <a:ext cx="11185855" cy="2920000"/>
+          </a:xfrm>
+          <a:prstGeom prst="roundRect">
+            <a:avLst>
+              <a:gd name="adj" fmla="val 3500"/>
+            </a:avLst>
+          </a:prstGeom>
+          <a:solidFill>
+            <a:srgbClr val="FFFFFF"/>
+          </a:solidFill>
+          <a:ln w="9525">
+            <a:solidFill>
+              <a:srgbClr val="ECE6DC"/>
+            </a:solidFill>
+          </a:ln>
+          <a:effectLst/>
+        </p:spPr>
+        <p:style>
+          <a:lnRef idx="1">
+            <a:schemeClr val="accent1"/>
+          </a:lnRef>
+          <a:fillRef idx="3">
+            <a:schemeClr val="accent1"/>
+          </a:fillRef>
+          <a:effectRef idx="2">
+            <a:schemeClr val="accent1"/>
+          </a:effectRef>
+          <a:fontRef idx="minor">
+            <a:schemeClr val="lt1"/>
+          </a:fontRef>
+        </p:style>
+        <p:txBody>
+          <a:bodyPr rtlCol="0" anchor="ctr"/>
+          <a:lstStyle/>
+          <a:p>
+            <a:pPr algn="ctr"/>
+          </a:p>
+        </p:txBody>
+      </p:sp>
+      <p:sp>
+        <p:nvSpPr>
+          <p:cNvPr id="5" name="TextBox 4"/>
+          <p:cNvSpPr txBox="1"/>
+          <p:nvPr/>
+        </p:nvSpPr>
+        <p:spPr>
+          <a:xfrm>
+            <a:off x="782920" y="1720000"/>
+            <a:ext cx="9625855" cy="360000"/>
+          </a:xfrm>
+          <a:prstGeom prst="rect">
+            <a:avLst/>
+          </a:prstGeom>
+          <a:noFill/>
+        </p:spPr>
+        <p:txBody>
+          <a:bodyPr wrap="square" anchor="t" lIns="0" rIns="0" tIns="0" bIns="0">
+            <a:spAutoFit/>
+          </a:bodyPr>
+          <a:lstStyle/>
+          <a:p>
+            <a:pPr algn="l"/>
+            <a:r>
+              <a:rPr sz="1500" b="1">
+                <a:solidFill>
+                  <a:srgbClr val="1A1A2E"/>
+                </a:solidFill>
+                <a:latin typeface="Segoe UI Semibold"/>
+              </a:rPr>
+              <a:t>Open items</a:t>
+            </a:r>
+          </a:p>
+        </p:txBody>
+      </p:sp>
+      <p:sp>
+        <p:nvSpPr>
+          <p:cNvPr id="6" name="TextBox 5"/>
+          <p:cNvSpPr txBox="1"/>
+          <p:nvPr/>
+        </p:nvSpPr>
+        <p:spPr>
+          <a:xfrm>
+            <a:off x="782920" y="2120000"/>
+            <a:ext cx="9625855" cy="2220000"/>
+          </a:xfrm>
+          <a:prstGeom prst="rect">
+            <a:avLst/>
+          </a:prstGeom>
+          <a:noFill/>
+        </p:spPr>
+        <p:txBody>
+          <a:bodyPr wrap="square" anchor="t" lIns="0" rIns="0" tIns="0" bIns="0">
+            <a:spAutoFit/>
+          </a:bodyPr>
+          <a:lstStyle/>
+          <a:p>
+            <a:pPr algn="l">
+              <a:lnSpc>
+                <a:spcPct val="115000"/>
+              </a:lnSpc>
+            </a:pPr>
+            <a:r>
+              <a:rPr sz="1100" b="0">
+                <a:solidFill>
+                  <a:srgbClr val="6B6558"/>
+                </a:solidFill>
+                <a:latin typeface="Segoe UI"/>
+              </a:rPr>
+              <a:t/>
+            </a:r>
+          </a:p>
+        </p:txBody>
+      </p:sp>
+      <p:sp>
+        <p:nvSpPr>
+          <p:cNvPr id="7" name="Rounded Rectangle 6"/>
+          <p:cNvSpPr/>
+          <p:nvPr/>
+        </p:nvSpPr>
+        <p:spPr>
+          <a:xfrm>
+            <a:off x="10408775" y="1760000"/>
+            <a:ext cx="1000000" cy="280000"/>
+          </a:xfrm>
+          <a:prstGeom prst="roundRect">
+            <a:avLst>
+              <a:gd name="adj" fmla="val 50000"/>
+            </a:avLst>
+          </a:prstGeom>
+          <a:solidFill>
+            <a:srgbClr val="FBE8D3"/>
+          </a:solidFill>
+          <a:ln>
+            <a:noFill/>
+          </a:ln>
+          <a:effectLst/>
+        </p:spPr>
+        <p:style>
+          <a:lnRef idx="1">
+            <a:schemeClr val="accent1"/>
+          </a:lnRef>
+          <a:fillRef idx="3">
+            <a:schemeClr val="accent1"/>
+          </a:fillRef>
+          <a:effectRef idx="2">
+            <a:schemeClr val="accent1"/>
+          </a:effectRef>
+          <a:fontRef idx="minor">
+            <a:schemeClr val="lt1"/>
+          </a:fontRef>
+        </p:style>
+        <p:txBody>
+          <a:bodyPr rtlCol="0" anchor="ctr" lIns="60000" rIns="60000" tIns="0" bIns="0"/>
+          <a:lstStyle/>
+          <a:p>
+            <a:pPr algn="ctr"/>
+            <a:r>
+              <a:rPr sz="1000" b="1">
+                <a:solidFill>
+                  <a:srgbClr val="9A5B0C"/>
+                </a:solidFill>
+                <a:latin typeface="Segoe UI Semibold"/>
+              </a:rPr>
+              <a:t>In progress</a:t>
+            </a:r>
+          </a:p>
+        </p:txBody>
+      </p:sp>
+      <p:sp>
+        <p:nvSpPr>
+          <p:cNvPr id="8" name="TextBox 7"/>
+          <p:cNvSpPr txBox="1"/>
+          <p:nvPr/>
+        </p:nvSpPr>
+        <p:spPr>
+          <a:xfrm>
+            <a:off x="782920" y="2160000"/>
+            <a:ext cx="4200000" cy="600000"/>
+          </a:xfrm>
+          <a:prstGeom prst="rect">
+            <a:avLst/>
+          </a:prstGeom>
+          <a:noFill/>
+        </p:spPr>
+        <p:txBody>
+          <a:bodyPr wrap="square" anchor="t" lIns="0" rIns="0" tIns="0" bIns="0">
+            <a:spAutoFit/>
+          </a:bodyPr>
+          <a:lstStyle/>
+          <a:p>
+            <a:pPr algn="l">
+              <a:lnSpc>
+                <a:spcPct val="110000"/>
+              </a:lnSpc>
+            </a:pPr>
+            <a:r>
+              <a:rPr sz="1100" b="0">
+                <a:solidFill>
+                  <a:srgbClr val="6B6558"/>
+                </a:solidFill>
+                <a:latin typeface="Segoe UI"/>
+              </a:rPr>
+              <a:t>Fix the double form-submission bug in shared hotel-search.js</a:t>
+            </a:r>
+          </a:p>
+        </p:txBody>
+      </p:sp>
+      <p:sp>
+        <p:nvSpPr>
+          <p:cNvPr id="9" name="TextBox 8"/>
+          <p:cNvSpPr txBox="1"/>
+          <p:nvPr/>
+        </p:nvSpPr>
+        <p:spPr>
+          <a:xfrm>
+            <a:off x="5102920" y="2160000"/>
+            <a:ext cx="6100000" cy="600000"/>
+          </a:xfrm>
+          <a:prstGeom prst="rect">
+            <a:avLst/>
+          </a:prstGeom>
+          <a:noFill/>
+        </p:spPr>
+        <p:txBody>
+          <a:bodyPr wrap="square" anchor="t" lIns="0" rIns="0" tIns="0" bIns="0">
+            <a:spAutoFit/>
+          </a:bodyPr>
+          <a:lstStyle/>
+          <a:p>
+            <a:pPr algn="l">
+              <a:lnSpc>
+                <a:spcPct val="110000"/>
+              </a:lnSpc>
+            </a:pPr>
+            <a:r>
+              <a:rPr sz="1100" b="1">
+                <a:solidFill>
+                  <a:srgbClr val="1A1A2E"/>
+                </a:solidFill>
+                <a:latin typeface="Segoe UI Semibold"/>
+              </a:rPr>
+              <a:t>Real, reproducible: two full AJAX submissions per single click, confirmed via console log. Doubles RateHawk call volume per search and can surface as a hard client-side error on a plain click — likely affects real production too, since it's shared code.</a:t>
+            </a:r>
+          </a:p>
+        </p:txBody>
+      </p:sp>
+      <p:sp>
+        <p:nvSpPr>
+          <p:cNvPr id="10" name="TextBox 9"/>
+          <p:cNvSpPr txBox="1"/>
+          <p:nvPr/>
+        </p:nvSpPr>
+        <p:spPr>
+          <a:xfrm>
+            <a:off x="782920" y="2760000"/>
+            <a:ext cx="4200000" cy="600000"/>
+          </a:xfrm>
+          <a:prstGeom prst="rect">
+            <a:avLst/>
+          </a:prstGeom>
+          <a:noFill/>
+        </p:spPr>
+        <p:txBody>
+          <a:bodyPr wrap="square" anchor="t" lIns="0" rIns="0" tIns="0" bIns="0">
+            <a:spAutoFit/>
+          </a:bodyPr>
+          <a:lstStyle/>
+          <a:p>
+            <a:pPr algn="l">
+              <a:lnSpc>
+                <a:spcPct val="110000"/>
+              </a:lnSpc>
+            </a:pPr>
+            <a:r>
+              <a:rPr sz="1100" b="0">
+                <a:solidFill>
+                  <a:srgbClr val="6B6558"/>
+                </a:solidFill>
+                <a:latin typeface="Segoe UI"/>
+              </a:rPr>
+              <a:t>Find the real bottleneck: the RateHawk/content fetch, not the DB fetch</a:t>
+            </a:r>
+          </a:p>
+        </p:txBody>
+      </p:sp>
+      <p:sp>
+        <p:nvSpPr>
+          <p:cNvPr id="11" name="TextBox 10"/>
+          <p:cNvSpPr txBox="1"/>
+          <p:nvPr/>
+        </p:nvSpPr>
+        <p:spPr>
+          <a:xfrm>
+            <a:off x="5102920" y="2760000"/>
+            <a:ext cx="6100000" cy="600000"/>
+          </a:xfrm>
+          <a:prstGeom prst="rect">
+            <a:avLst/>
+          </a:prstGeom>
+          <a:noFill/>
+        </p:spPr>
+        <p:txBody>
+          <a:bodyPr wrap="square" anchor="t" lIns="0" rIns="0" tIns="0" bIns="0">
+            <a:spAutoFit/>
+          </a:bodyPr>
+          <a:lstStyle/>
+          <a:p>
+            <a:pPr algn="l">
+              <a:lnSpc>
+                <a:spcPct val="110000"/>
+              </a:lnSpc>
+            </a:pPr>
+            <a:r>
+              <a:rPr sz="1100" b="1">
+                <a:solidFill>
+                  <a:srgbClr val="1A1A2E"/>
+                </a:solidFill>
+                <a:latin typeface="Segoe UI Semibold"/>
+              </a:rPr>
+              <a:t>It's 65.5% of the 24.8s total; today's DB fixes touch a much smaller slice. The still-MySQL-sourced amenities query and filter/sort work dominate on both sides — that's where the next real win has to come from.</a:t>
+            </a:r>
+          </a:p>
+        </p:txBody>
+      </p:sp>
+      <p:sp>
+        <p:nvSpPr>
+          <p:cNvPr id="12" name="TextBox 11"/>
+          <p:cNvSpPr txBox="1"/>
+          <p:nvPr/>
+        </p:nvSpPr>
+        <p:spPr>
+          <a:xfrm>
+            <a:off x="782920" y="3360000"/>
+            <a:ext cx="4200000" cy="600000"/>
+          </a:xfrm>
+          <a:prstGeom prst="rect">
+            <a:avLst/>
+          </a:prstGeom>
+          <a:noFill/>
+        </p:spPr>
+        <p:txBody>
+          <a:bodyPr wrap="square" anchor="t" lIns="0" rIns="0" tIns="0" bIns="0">
+            <a:spAutoFit/>
+          </a:bodyPr>
+          <a:lstStyle/>
+          <a:p>
+            <a:pPr algn="l">
+              <a:lnSpc>
+                <a:spcPct val="110000"/>
+              </a:lnSpc>
+            </a:pPr>
+            <a:r>
+              <a:rPr sz="1100" b="0">
+                <a:solidFill>
+                  <a:srgbClr val="6B6558"/>
+                </a:solidFill>
+                <a:latin typeface="Segoe UI"/>
+              </a:rPr>
+              <a:t>Flag the today's-date plugin-directory incident to Hristijan</a:t>
+            </a:r>
+          </a:p>
+        </p:txBody>
+      </p:sp>
+      <p:sp>
+        <p:nvSpPr>
+          <p:cNvPr id="13" name="TextBox 12"/>
+          <p:cNvSpPr txBox="1"/>
+          <p:nvPr/>
+        </p:nvSpPr>
+        <p:spPr>
+          <a:xfrm>
+            <a:off x="5102920" y="3360000"/>
+            <a:ext cx="6100000" cy="600000"/>
+          </a:xfrm>
+          <a:prstGeom prst="rect">
+            <a:avLst/>
+          </a:prstGeom>
+          <a:noFill/>
+        </p:spPr>
+        <p:txBody>
+          <a:bodyPr wrap="square" anchor="t" lIns="0" rIns="0" tIns="0" bIns="0">
+            <a:spAutoFit/>
+          </a:bodyPr>
+          <a:lstStyle/>
+          <a:p>
+            <a:pPr algn="l">
+              <a:lnSpc>
+                <a:spcPct val="110000"/>
+              </a:lnSpc>
+            </a:pPr>
+            <a:r>
+              <a:rPr sz="1100" b="1">
+                <a:solidFill>
+                  <a:srgbClr val="1A1A2E"/>
+                </a:solidFill>
+                <a:latin typeface="Segoe UI Semibold"/>
+              </a:rPr>
+              <a:t>Something outside this session replaced wp-content/plugins/ today, wiping the fork's files — worth checking blast radius on other plugins</a:t>
+            </a:r>
+          </a:p>
+        </p:txBody>
+      </p:sp>
+      <p:sp>
+        <p:nvSpPr>
+          <p:cNvPr id="14" name="TextBox 13"/>
+          <p:cNvSpPr txBox="1"/>
+          <p:nvPr/>
+        </p:nvSpPr>
+        <p:spPr>
+          <a:xfrm>
+            <a:off x="782920" y="3960000"/>
+            <a:ext cx="4200000" cy="340000"/>
+          </a:xfrm>
+          <a:prstGeom prst="rect">
+            <a:avLst/>
+          </a:prstGeom>
+          <a:noFill/>
+        </p:spPr>
+        <p:txBody>
+          <a:bodyPr wrap="square" anchor="t" lIns="0" rIns="0" tIns="0" bIns="0">
+            <a:spAutoFit/>
+          </a:bodyPr>
+          <a:lstStyle/>
+          <a:p>
+            <a:pPr algn="l">
+              <a:lnSpc>
+                <a:spcPct val="110000"/>
+              </a:lnSpc>
+            </a:pPr>
+            <a:r>
+              <a:rPr sz="1100" b="0">
+                <a:solidFill>
+                  <a:srgbClr val="6B6558"/>
+                </a:solidFill>
+                <a:latin typeface="Segoe UI"/>
+              </a:rPr>
+              <a:t>Real production page still renders blank</a:t>
+            </a:r>
+          </a:p>
+        </p:txBody>
+      </p:sp>
+      <p:sp>
+        <p:nvSpPr>
+          <p:cNvPr id="15" name="TextBox 14"/>
+          <p:cNvSpPr txBox="1"/>
+          <p:nvPr/>
+        </p:nvSpPr>
+        <p:spPr>
+          <a:xfrm>
+            <a:off x="5102920" y="3960000"/>
+            <a:ext cx="6100000" cy="340000"/>
+          </a:xfrm>
+          <a:prstGeom prst="rect">
+            <a:avLst/>
+          </a:prstGeom>
+          <a:noFill/>
+        </p:spPr>
+        <p:txBody>
+          <a:bodyPr wrap="square" anchor="t" lIns="0" rIns="0" tIns="0" bIns="0">
+            <a:spAutoFit/>
+          </a:bodyPr>
+          <a:lstStyle/>
+          <a:p>
+            <a:pPr algn="l">
+              <a:lnSpc>
+                <a:spcPct val="110000"/>
+              </a:lnSpc>
+            </a:pPr>
+            <a:r>
+              <a:rPr sz="1100" b="1">
+                <a:solidFill>
+                  <a:srgbClr val="1A1A2E"/>
+                </a:solidFill>
+                <a:latin typeface="Segoe UI Semibold"/>
+              </a:rPr>
+              <a:t>Pre-existing, confirmed unrelated to this work — needs separate investigation on the tech team's side</a:t>
+            </a:r>
+          </a:p>
+        </p:txBody>
+      </p:sp>
+      <p:sp>
+        <p:nvSpPr>
+          <p:cNvPr id="16" name="TextBox 15"/>
+          <p:cNvSpPr txBox="1"/>
+          <p:nvPr/>
+        </p:nvSpPr>
+        <p:spPr>
+          <a:xfrm>
+            <a:off x="502920" y="6518000"/>
+            <a:ext cx="9000000" cy="240000"/>
+          </a:xfrm>
+          <a:prstGeom prst="rect">
+            <a:avLst/>
+          </a:prstGeom>
+          <a:noFill/>
+        </p:spPr>
+        <p:txBody>
+          <a:bodyPr wrap="square" anchor="t" lIns="0" rIns="0" tIns="0" bIns="0">
+            <a:spAutoFit/>
+          </a:bodyPr>
+          <a:lstStyle/>
+          <a:p>
+            <a:pPr algn="l"/>
+            <a:r>
+              <a:rPr sz="900" b="0">
+                <a:solidFill>
+                  <a:srgbClr val="9B9384"/>
+                </a:solidFill>
+                <a:latin typeface="Segoe UI"/>
+              </a:rPr>
+              <a:t>BALKANEA WEB  •  SUPABASE VS MYSQL COMPARISON</a:t>
+            </a:r>
+          </a:p>
+        </p:txBody>
+      </p:sp>
+      <p:sp>
+        <p:nvSpPr>
+          <p:cNvPr id="17" name="TextBox 16"/>
+          <p:cNvSpPr txBox="1"/>
+          <p:nvPr/>
+        </p:nvSpPr>
+        <p:spPr>
+          <a:xfrm>
+            <a:off x="11492000" y="6518000"/>
+            <a:ext cx="400000" cy="240000"/>
+          </a:xfrm>
+          <a:prstGeom prst="rect">
+            <a:avLst/>
+          </a:prstGeom>
+          <a:noFill/>
+        </p:spPr>
+        <p:txBody>
+          <a:bodyPr wrap="square" anchor="t" lIns="0" rIns="0" tIns="0" bIns="0">
+            <a:spAutoFit/>
+          </a:bodyPr>
+          <a:lstStyle/>
+          <a:p>
+            <a:pPr algn="r"/>
+            <a:r>
+              <a:rPr sz="900" b="0">
+                <a:solidFill>
+                  <a:srgbClr val="9B9384"/>
+                </a:solidFill>
+                <a:latin typeface="Segoe UI"/>
+              </a:rPr>
+              <a:t>10</a:t>
             </a:r>
           </a:p>
         </p:txBody>
@@ -6081,7 +6934,7 @@
                 </a:solidFill>
                 <a:latin typeface="Segoe UI Semibold"/>
               </a:rPr>
-              <a:t>Full search, real Athens query, same dates on both sides</a:t>
+              <a:t>Re-run 2026-09-15 — real Athens query, two fresh date ranges, both run orders</a:t>
             </a:r>
           </a:p>
         </p:txBody>
@@ -6182,7 +7035,7 @@
                 </a:solidFill>
                 <a:latin typeface="Segoe UI Semibold"/>
               </a:rPr>
-              <a:t>Real production is faster, cold and warm</a:t>
+              <a:t>Both sides got much slower since 9/14 — and it's not the database</a:t>
             </a:r>
           </a:p>
         </p:txBody>
@@ -6221,7 +7074,7 @@
                 </a:solidFill>
                 <a:latin typeface="Segoe UI"/>
               </a:rPr>
-              <a:t>MySQL is ahead by roughly 20–30% at every point measured (14.1s vs 17.7s cold; 9.9s vs 12.4s warm). This matches the pre-existing baseline from earlier testing this week — today's DB fixes didn't close the gap.</a:t>
+              <a:t>MySQL now settles in 67–77s, Supabase in 112–122s — both far above the 14–18s baseline from 9/14. The Supabase-slower gap holds in BOTH run orders (MySQL-first and Supabase-first), so it isn't a warm-cache artifact — something got worse on both sides.</a:t>
             </a:r>
           </a:p>
         </p:txBody>
@@ -6304,7 +7157,7 @@
                 </a:solidFill>
                 <a:latin typeface="Segoe UI Semibold"/>
               </a:rPr>
-              <a:t>Why: chunk time isn't mostly DB time</a:t>
+              <a:t>Why: a repeating/duplicate request loop, worse on Supabase</a:t>
             </a:r>
           </a:p>
         </p:txBody>
@@ -6343,7 +7196,7 @@
                 </a:solidFill>
                 <a:latin typeface="Segoe UI"/>
               </a:rPr>
-              <a:t>Each chunk runs 3.3–4.5s, but the isolated DB fetch today's fixes target is ~350ms of that. The rest — the still-MySQL-sourced amenities query, filter/sort work — is shared architecture on both sides, and is where the next win likely has to come from.</a:t>
+              <a:t>Even driven by URL navigation (not a Search click), both sides fire literal duplicate concurrent chunk requests and keep polling every ~4s well after real results stop growing. Supabase's final hotel count (578–633) is ~2x MySQL's (295–326) for the identical query — almost certainly duplicated chunks, not real extra inventory.</a:t>
             </a:r>
           </a:p>
         </p:txBody>
@@ -6382,7 +7235,7 @@
                 </a:solidFill>
                 <a:latin typeface="Segoe UI"/>
               </a:rPr>
-              <a:t>Method: direct AJAX timing (initial + all DB chunks, real Athens search, same 14–15 Sep dates and guest params on both sides, 259–266 hotels, 3 backend round-trips) — bypasses browser render time so it isolates backend behavior equally. An earlier pass used a different, heavier date range and produced inflated, non-comparable numbers — discarded.</a:t>
+              <a:t>Method: direct URL navigation (bypasses the known Search-click double-submit path), Performance Resource Timing on admin-ajax.php, two Athens date ranges not touched in prior testing, each side run both first and second to rule out order/warm-cache bias. “Settled” = displayed hotel count and request count both unchanged for 20–30s. Full raw timings in Mobile/decks/perf_runs.json.</a:t>
             </a:r>
           </a:p>
         </p:txBody>
@@ -7065,7 +7918,7 @@
                 </a:solidFill>
                 <a:latin typeface="Segoe UI Semibold"/>
               </a:rPr>
-              <a:t>06  —  NEXT STEPS</a:t>
+              <a:t>06  —  TEST SITE 3</a:t>
             </a:r>
           </a:p>
         </p:txBody>
@@ -7100,7 +7953,7 @@
                 </a:solidFill>
                 <a:latin typeface="Segoe UI Semibold"/>
               </a:rPr>
-              <a:t>Open items and where this goes next</a:t>
+              <a:t>A third variant built to chase a 3–5s render — and the honest result</a:t>
             </a:r>
           </a:p>
         </p:txBody>
@@ -7114,7 +7967,7 @@
         <p:spPr>
           <a:xfrm>
             <a:off x="502920" y="1560000"/>
-            <a:ext cx="11185855" cy="2820000"/>
+            <a:ext cx="11185855" cy="1150000"/>
           </a:xfrm>
           <a:prstGeom prst="roundRect">
             <a:avLst>
@@ -7183,7 +8036,7 @@
                 </a:solidFill>
                 <a:latin typeface="Segoe UI Semibold"/>
               </a:rPr>
-              <a:t>Open items</a:t>
+              <a:t>What was built — “?fast=1” on the same comparison URL</a:t>
             </a:r>
           </a:p>
         </p:txBody>
@@ -7197,7 +8050,7 @@
         <p:spPr>
           <a:xfrm>
             <a:off x="782920" y="2120000"/>
-            <a:ext cx="9625855" cy="2120000"/>
+            <a:ext cx="9625855" cy="450000"/>
           </a:xfrm>
           <a:prstGeom prst="rect">
             <a:avLst/>
@@ -7222,7 +8075,7 @@
                 </a:solidFill>
                 <a:latin typeface="Segoe UI"/>
               </a:rPr>
-              <a:t/>
+              <a:t>A front-end skeleton-loading overlay (6 pulsing placeholder cards) fires the instant Search is clicked, replacing the spinner-only wait. Verified live: appears synchronously on click, is cleanly replaced by real results with no errors. It changes what the wait feels like — it does not, and was never claimed to, change the real backend timing.</a:t>
             </a:r>
           </a:p>
         </p:txBody>
@@ -7236,6 +8089,183 @@
         <p:spPr>
           <a:xfrm>
             <a:off x="10408775" y="1760000"/>
+            <a:ext cx="1000000" cy="280000"/>
+          </a:xfrm>
+          <a:prstGeom prst="roundRect">
+            <a:avLst>
+              <a:gd name="adj" fmla="val 50000"/>
+            </a:avLst>
+          </a:prstGeom>
+          <a:solidFill>
+            <a:srgbClr val="E1EFE6"/>
+          </a:solidFill>
+          <a:ln>
+            <a:noFill/>
+          </a:ln>
+          <a:effectLst/>
+        </p:spPr>
+        <p:style>
+          <a:lnRef idx="1">
+            <a:schemeClr val="accent1"/>
+          </a:lnRef>
+          <a:fillRef idx="3">
+            <a:schemeClr val="accent1"/>
+          </a:fillRef>
+          <a:effectRef idx="2">
+            <a:schemeClr val="accent1"/>
+          </a:effectRef>
+          <a:fontRef idx="minor">
+            <a:schemeClr val="lt1"/>
+          </a:fontRef>
+        </p:style>
+        <p:txBody>
+          <a:bodyPr rtlCol="0" anchor="ctr" lIns="60000" rIns="60000" tIns="0" bIns="0"/>
+          <a:lstStyle/>
+          <a:p>
+            <a:pPr algn="ctr"/>
+            <a:r>
+              <a:rPr sz="1000" b="1">
+                <a:solidFill>
+                  <a:srgbClr val="1F7A4D"/>
+                </a:solidFill>
+                <a:latin typeface="Segoe UI Semibold"/>
+              </a:rPr>
+              <a:t>Shipped</a:t>
+            </a:r>
+          </a:p>
+        </p:txBody>
+      </p:sp>
+      <p:sp>
+        <p:nvSpPr>
+          <p:cNvPr id="8" name="Rounded Rectangle 7"/>
+          <p:cNvSpPr/>
+          <p:nvPr/>
+        </p:nvSpPr>
+        <p:spPr>
+          <a:xfrm>
+            <a:off x="502920" y="2810000"/>
+            <a:ext cx="11185855" cy="1150000"/>
+          </a:xfrm>
+          <a:prstGeom prst="roundRect">
+            <a:avLst>
+              <a:gd name="adj" fmla="val 3500"/>
+            </a:avLst>
+          </a:prstGeom>
+          <a:solidFill>
+            <a:srgbClr val="FFFFFF"/>
+          </a:solidFill>
+          <a:ln w="9525">
+            <a:solidFill>
+              <a:srgbClr val="ECE6DC"/>
+            </a:solidFill>
+          </a:ln>
+          <a:effectLst/>
+        </p:spPr>
+        <p:style>
+          <a:lnRef idx="1">
+            <a:schemeClr val="accent1"/>
+          </a:lnRef>
+          <a:fillRef idx="3">
+            <a:schemeClr val="accent1"/>
+          </a:fillRef>
+          <a:effectRef idx="2">
+            <a:schemeClr val="accent1"/>
+          </a:effectRef>
+          <a:fontRef idx="minor">
+            <a:schemeClr val="lt1"/>
+          </a:fontRef>
+        </p:style>
+        <p:txBody>
+          <a:bodyPr rtlCol="0" anchor="ctr"/>
+          <a:lstStyle/>
+          <a:p>
+            <a:pPr algn="ctr"/>
+          </a:p>
+        </p:txBody>
+      </p:sp>
+      <p:sp>
+        <p:nvSpPr>
+          <p:cNvPr id="9" name="TextBox 8"/>
+          <p:cNvSpPr txBox="1"/>
+          <p:nvPr/>
+        </p:nvSpPr>
+        <p:spPr>
+          <a:xfrm>
+            <a:off x="782920" y="2970000"/>
+            <a:ext cx="9625855" cy="360000"/>
+          </a:xfrm>
+          <a:prstGeom prst="rect">
+            <a:avLst/>
+          </a:prstGeom>
+          <a:noFill/>
+        </p:spPr>
+        <p:txBody>
+          <a:bodyPr wrap="square" anchor="t" lIns="0" rIns="0" tIns="0" bIns="0">
+            <a:spAutoFit/>
+          </a:bodyPr>
+          <a:lstStyle/>
+          <a:p>
+            <a:pPr algn="l"/>
+            <a:r>
+              <a:rPr sz="1500" b="1">
+                <a:solidFill>
+                  <a:srgbClr val="1A1A2E"/>
+                </a:solidFill>
+                <a:latin typeface="Segoe UI Semibold"/>
+              </a:rPr>
+              <a:t>One lever intentionally not pursued: RateHawk's own hotels_limit</a:t>
+            </a:r>
+          </a:p>
+        </p:txBody>
+      </p:sp>
+      <p:sp>
+        <p:nvSpPr>
+          <p:cNvPr id="10" name="TextBox 9"/>
+          <p:cNvSpPr txBox="1"/>
+          <p:nvPr/>
+        </p:nvSpPr>
+        <p:spPr>
+          <a:xfrm>
+            <a:off x="782920" y="3370000"/>
+            <a:ext cx="9625855" cy="450000"/>
+          </a:xfrm>
+          <a:prstGeom prst="rect">
+            <a:avLst/>
+          </a:prstGeom>
+          <a:noFill/>
+        </p:spPr>
+        <p:txBody>
+          <a:bodyPr wrap="square" anchor="t" lIns="0" rIns="0" tIns="0" bIns="0">
+            <a:spAutoFit/>
+          </a:bodyPr>
+          <a:lstStyle/>
+          <a:p>
+            <a:pPr algn="l">
+              <a:lnSpc>
+                <a:spcPct val="115000"/>
+              </a:lnSpc>
+            </a:pPr>
+            <a:r>
+              <a:rPr sz="1100" b="0">
+                <a:solidFill>
+                  <a:srgbClr val="6B6558"/>
+                </a:solidFill>
+                <a:latin typeface="Segoe UI"/>
+              </a:rPr>
+              <a:t>Production's WorldotaProvider.php has a commented-out hotels_limit parameter that could shrink the live RateHawk response itself. Implementing it requires copying a file containing embedded API credentials — blocked by this session's own credential-handling safeguards. Skipped rather than worked around; flagged below for Hristijan's team to test directly on their own file.</a:t>
+            </a:r>
+          </a:p>
+        </p:txBody>
+      </p:sp>
+      <p:sp>
+        <p:nvSpPr>
+          <p:cNvPr id="11" name="Rounded Rectangle 10"/>
+          <p:cNvSpPr/>
+          <p:nvPr/>
+        </p:nvSpPr>
+        <p:spPr>
+          <a:xfrm>
+            <a:off x="10408775" y="3010000"/>
             <a:ext cx="1000000" cy="280000"/>
           </a:xfrm>
           <a:prstGeom prst="roundRect">
@@ -7277,21 +8307,559 @@
                 </a:solidFill>
                 <a:latin typeface="Segoe UI Semibold"/>
               </a:rPr>
-              <a:t>In progress</a:t>
-            </a:r>
-          </a:p>
-        </p:txBody>
-      </p:sp>
-      <p:sp>
-        <p:nvSpPr>
-          <p:cNvPr id="8" name="TextBox 7"/>
-          <p:cNvSpPr txBox="1"/>
-          <p:nvPr/>
-        </p:nvSpPr>
-        <p:spPr>
-          <a:xfrm>
-            <a:off x="782920" y="2160000"/>
-            <a:ext cx="4200000" cy="600000"/>
+              <a:t>Skipped</a:t>
+            </a:r>
+          </a:p>
+        </p:txBody>
+      </p:sp>
+      <p:sp>
+        <p:nvSpPr>
+          <p:cNvPr id="12" name="Rounded Rectangle 11"/>
+          <p:cNvSpPr/>
+          <p:nvPr/>
+        </p:nvSpPr>
+        <p:spPr>
+          <a:xfrm>
+            <a:off x="502920" y="4060000"/>
+            <a:ext cx="11185855" cy="1450000"/>
+          </a:xfrm>
+          <a:prstGeom prst="roundRect">
+            <a:avLst>
+              <a:gd name="adj" fmla="val 3500"/>
+            </a:avLst>
+          </a:prstGeom>
+          <a:solidFill>
+            <a:srgbClr val="FFFFFF"/>
+          </a:solidFill>
+          <a:ln w="9525">
+            <a:solidFill>
+              <a:srgbClr val="ECE6DC"/>
+            </a:solidFill>
+          </a:ln>
+          <a:effectLst/>
+        </p:spPr>
+        <p:style>
+          <a:lnRef idx="1">
+            <a:schemeClr val="accent1"/>
+          </a:lnRef>
+          <a:fillRef idx="3">
+            <a:schemeClr val="accent1"/>
+          </a:fillRef>
+          <a:effectRef idx="2">
+            <a:schemeClr val="accent1"/>
+          </a:effectRef>
+          <a:fontRef idx="minor">
+            <a:schemeClr val="lt1"/>
+          </a:fontRef>
+        </p:style>
+        <p:txBody>
+          <a:bodyPr rtlCol="0" anchor="ctr"/>
+          <a:lstStyle/>
+          <a:p>
+            <a:pPr algn="ctr"/>
+          </a:p>
+        </p:txBody>
+      </p:sp>
+      <p:sp>
+        <p:nvSpPr>
+          <p:cNvPr id="13" name="TextBox 12"/>
+          <p:cNvSpPr txBox="1"/>
+          <p:nvPr/>
+        </p:nvSpPr>
+        <p:spPr>
+          <a:xfrm>
+            <a:off x="782920" y="4220000"/>
+            <a:ext cx="9625855" cy="360000"/>
+          </a:xfrm>
+          <a:prstGeom prst="rect">
+            <a:avLst/>
+          </a:prstGeom>
+          <a:noFill/>
+        </p:spPr>
+        <p:txBody>
+          <a:bodyPr wrap="square" anchor="t" lIns="0" rIns="0" tIns="0" bIns="0">
+            <a:spAutoFit/>
+          </a:bodyPr>
+          <a:lstStyle/>
+          <a:p>
+            <a:pPr algn="l"/>
+            <a:r>
+              <a:rPr sz="1500" b="1">
+                <a:solidFill>
+                  <a:srgbClr val="1A1A2E"/>
+                </a:solidFill>
+                <a:latin typeface="Segoe UI Semibold"/>
+              </a:rPr>
+              <a:t>The honest number: 3–5s is not achieved for a genuinely cold first search</a:t>
+            </a:r>
+          </a:p>
+        </p:txBody>
+      </p:sp>
+      <p:sp>
+        <p:nvSpPr>
+          <p:cNvPr id="14" name="TextBox 13"/>
+          <p:cNvSpPr txBox="1"/>
+          <p:nvPr/>
+        </p:nvSpPr>
+        <p:spPr>
+          <a:xfrm>
+            <a:off x="782920" y="4620000"/>
+            <a:ext cx="9625855" cy="750000"/>
+          </a:xfrm>
+          <a:prstGeom prst="rect">
+            <a:avLst/>
+          </a:prstGeom>
+          <a:noFill/>
+        </p:spPr>
+        <p:txBody>
+          <a:bodyPr wrap="square" anchor="t" lIns="0" rIns="0" tIns="0" bIns="0">
+            <a:spAutoFit/>
+          </a:bodyPr>
+          <a:lstStyle/>
+          <a:p>
+            <a:pPr algn="l">
+              <a:lnSpc>
+                <a:spcPct val="115000"/>
+              </a:lnSpc>
+            </a:pPr>
+            <a:r>
+              <a:rPr sz="1100" b="0">
+                <a:solidFill>
+                  <a:srgbClr val="6B6558"/>
+                </a:solidFill>
+                <a:latin typeface="Segoe UI"/>
+              </a:rPr>
+              <a:t>Measured with a MutationObserver on the real click-to-render path (not polling, which earlier gave false 30–45s “stall” readings that turned out to just be the polling interval). Best clean real-content case on a small, never-cached destination: 11.0s. On Athens — the flagship, highest-inventory destination — a genuinely cold run measured 24.8s end to end. See the next slide for exactly where that time goes.</a:t>
+            </a:r>
+          </a:p>
+        </p:txBody>
+      </p:sp>
+      <p:sp>
+        <p:nvSpPr>
+          <p:cNvPr id="15" name="Rounded Rectangle 14"/>
+          <p:cNvSpPr/>
+          <p:nvPr/>
+        </p:nvSpPr>
+        <p:spPr>
+          <a:xfrm>
+            <a:off x="10408775" y="4260000"/>
+            <a:ext cx="1000000" cy="280000"/>
+          </a:xfrm>
+          <a:prstGeom prst="roundRect">
+            <a:avLst>
+              <a:gd name="adj" fmla="val 50000"/>
+            </a:avLst>
+          </a:prstGeom>
+          <a:solidFill>
+            <a:srgbClr val="DDE9F7"/>
+          </a:solidFill>
+          <a:ln>
+            <a:noFill/>
+          </a:ln>
+          <a:effectLst/>
+        </p:spPr>
+        <p:style>
+          <a:lnRef idx="1">
+            <a:schemeClr val="accent1"/>
+          </a:lnRef>
+          <a:fillRef idx="3">
+            <a:schemeClr val="accent1"/>
+          </a:fillRef>
+          <a:effectRef idx="2">
+            <a:schemeClr val="accent1"/>
+          </a:effectRef>
+          <a:fontRef idx="minor">
+            <a:schemeClr val="lt1"/>
+          </a:fontRef>
+        </p:style>
+        <p:txBody>
+          <a:bodyPr rtlCol="0" anchor="ctr" lIns="60000" rIns="60000" tIns="0" bIns="0"/>
+          <a:lstStyle/>
+          <a:p>
+            <a:pPr algn="ctr"/>
+            <a:r>
+              <a:rPr sz="1000" b="1">
+                <a:solidFill>
+                  <a:srgbClr val="1C4E80"/>
+                </a:solidFill>
+                <a:latin typeface="Segoe UI Semibold"/>
+              </a:rPr>
+              <a:t>Measured</a:t>
+            </a:r>
+          </a:p>
+        </p:txBody>
+      </p:sp>
+      <p:sp>
+        <p:nvSpPr>
+          <p:cNvPr id="16" name="TextBox 15"/>
+          <p:cNvSpPr txBox="1"/>
+          <p:nvPr/>
+        </p:nvSpPr>
+        <p:spPr>
+          <a:xfrm>
+            <a:off x="502920" y="6518000"/>
+            <a:ext cx="9000000" cy="240000"/>
+          </a:xfrm>
+          <a:prstGeom prst="rect">
+            <a:avLst/>
+          </a:prstGeom>
+          <a:noFill/>
+        </p:spPr>
+        <p:txBody>
+          <a:bodyPr wrap="square" anchor="t" lIns="0" rIns="0" tIns="0" bIns="0">
+            <a:spAutoFit/>
+          </a:bodyPr>
+          <a:lstStyle/>
+          <a:p>
+            <a:pPr algn="l"/>
+            <a:r>
+              <a:rPr sz="900" b="0">
+                <a:solidFill>
+                  <a:srgbClr val="9B9384"/>
+                </a:solidFill>
+                <a:latin typeface="Segoe UI"/>
+              </a:rPr>
+              <a:t>BALKANEA WEB  •  SUPABASE VS MYSQL COMPARISON</a:t>
+            </a:r>
+          </a:p>
+        </p:txBody>
+      </p:sp>
+      <p:sp>
+        <p:nvSpPr>
+          <p:cNvPr id="17" name="TextBox 16"/>
+          <p:cNvSpPr txBox="1"/>
+          <p:nvPr/>
+        </p:nvSpPr>
+        <p:spPr>
+          <a:xfrm>
+            <a:off x="11492000" y="6518000"/>
+            <a:ext cx="400000" cy="240000"/>
+          </a:xfrm>
+          <a:prstGeom prst="rect">
+            <a:avLst/>
+          </a:prstGeom>
+          <a:noFill/>
+        </p:spPr>
+        <p:txBody>
+          <a:bodyPr wrap="square" anchor="t" lIns="0" rIns="0" tIns="0" bIns="0">
+            <a:spAutoFit/>
+          </a:bodyPr>
+          <a:lstStyle/>
+          <a:p>
+            <a:pPr algn="r"/>
+            <a:r>
+              <a:rPr sz="900" b="0">
+                <a:solidFill>
+                  <a:srgbClr val="9B9384"/>
+                </a:solidFill>
+                <a:latin typeface="Segoe UI"/>
+              </a:rPr>
+              <a:t>7</a:t>
+            </a:r>
+          </a:p>
+        </p:txBody>
+      </p:sp>
+    </p:spTree>
+  </p:cSld>
+  <p:clrMapOvr>
+    <a:masterClrMapping/>
+  </p:clrMapOvr>
+</p:sld>
+</file>
+
+<file path=ppt/slides/slide8.xml><?xml version="1.0" encoding="utf-8"?>
+<p:sld xmlns:a="http://schemas.openxmlformats.org/drawingml/2006/main" xmlns:p="http://schemas.openxmlformats.org/presentationml/2006/main" xmlns:r="http://schemas.openxmlformats.org/officeDocument/2006/relationships">
+  <p:cSld>
+    <p:bg>
+      <p:bgPr>
+        <a:solidFill>
+          <a:srgbClr val="FAF7F2"/>
+        </a:solidFill>
+        <a:effectLst/>
+      </p:bgPr>
+    </p:bg>
+    <p:spTree>
+      <p:nvGrpSpPr>
+        <p:cNvPr id="1" name=""/>
+        <p:cNvGrpSpPr/>
+        <p:nvPr/>
+      </p:nvGrpSpPr>
+      <p:grpSpPr/>
+      <p:sp>
+        <p:nvSpPr>
+          <p:cNvPr id="2" name="TextBox 1"/>
+          <p:cNvSpPr txBox="1"/>
+          <p:nvPr/>
+        </p:nvSpPr>
+        <p:spPr>
+          <a:xfrm>
+            <a:off x="502920" y="560000"/>
+            <a:ext cx="11185855" cy="300000"/>
+          </a:xfrm>
+          <a:prstGeom prst="rect">
+            <a:avLst/>
+          </a:prstGeom>
+          <a:noFill/>
+        </p:spPr>
+        <p:txBody>
+          <a:bodyPr wrap="square" anchor="t" lIns="0" rIns="0" tIns="0" bIns="0">
+            <a:spAutoFit/>
+          </a:bodyPr>
+          <a:lstStyle/>
+          <a:p>
+            <a:pPr algn="l"/>
+            <a:r>
+              <a:rPr sz="1300" b="1">
+                <a:solidFill>
+                  <a:srgbClr val="7A3E0F"/>
+                </a:solidFill>
+                <a:latin typeface="Segoe UI Semibold"/>
+              </a:rPr>
+              <a:t>07  —  WHERE THE TIME GOES</a:t>
+            </a:r>
+          </a:p>
+        </p:txBody>
+      </p:sp>
+      <p:sp>
+        <p:nvSpPr>
+          <p:cNvPr id="3" name="TextBox 2"/>
+          <p:cNvSpPr txBox="1"/>
+          <p:nvPr/>
+        </p:nvSpPr>
+        <p:spPr>
+          <a:xfrm>
+            <a:off x="502920" y="880000"/>
+            <a:ext cx="11185855" cy="500000"/>
+          </a:xfrm>
+          <a:prstGeom prst="rect">
+            <a:avLst/>
+          </a:prstGeom>
+          <a:noFill/>
+        </p:spPr>
+        <p:txBody>
+          <a:bodyPr wrap="square" anchor="t" lIns="0" rIns="0" tIns="0" bIns="0">
+            <a:spAutoFit/>
+          </a:bodyPr>
+          <a:lstStyle/>
+          <a:p>
+            <a:pPr algn="l"/>
+            <a:r>
+              <a:rPr sz="2400" b="1">
+                <a:solidFill>
+                  <a:srgbClr val="1A1A2E"/>
+                </a:solidFill>
+                <a:latin typeface="Segoe UI Semibold"/>
+              </a:rPr>
+              <a:t>Athens, cold search, click → hotels on screen: 24.8s broken down</a:t>
+            </a:r>
+          </a:p>
+        </p:txBody>
+      </p:sp>
+      <p:graphicFrame>
+        <p:nvGraphicFramePr>
+          <p:cNvPr id="4" name="Chart 3"/>
+          <p:cNvGraphicFramePr>
+            <a:graphicFrameLocks noGrp="1"/>
+          </p:cNvGraphicFramePr>
+          <p:nvPr/>
+        </p:nvGraphicFramePr>
+        <p:xfrm>
+          <a:off x="502920" y="1550000"/>
+          <a:ext cx="7300000" cy="1500000"/>
+        </p:xfrm>
+        <a:graphic>
+          <a:graphicData uri="http://schemas.openxmlformats.org/drawingml/2006/chart">
+            <c:chart xmlns:c="http://schemas.openxmlformats.org/drawingml/2006/chart" r:id="rId2"/>
+          </a:graphicData>
+        </a:graphic>
+      </p:graphicFrame>
+      <p:sp>
+        <p:nvSpPr>
+          <p:cNvPr id="5" name="Rounded Rectangle 4"/>
+          <p:cNvSpPr/>
+          <p:nvPr/>
+        </p:nvSpPr>
+        <p:spPr>
+          <a:xfrm>
+            <a:off x="502920" y="3150000"/>
+            <a:ext cx="11185855" cy="2200000"/>
+          </a:xfrm>
+          <a:prstGeom prst="roundRect">
+            <a:avLst>
+              <a:gd name="adj" fmla="val 3500"/>
+            </a:avLst>
+          </a:prstGeom>
+          <a:solidFill>
+            <a:srgbClr val="FFFFFF"/>
+          </a:solidFill>
+          <a:ln w="9525">
+            <a:solidFill>
+              <a:srgbClr val="ECE6DC"/>
+            </a:solidFill>
+          </a:ln>
+          <a:effectLst/>
+        </p:spPr>
+        <p:style>
+          <a:lnRef idx="1">
+            <a:schemeClr val="accent1"/>
+          </a:lnRef>
+          <a:fillRef idx="3">
+            <a:schemeClr val="accent1"/>
+          </a:fillRef>
+          <a:effectRef idx="2">
+            <a:schemeClr val="accent1"/>
+          </a:effectRef>
+          <a:fontRef idx="minor">
+            <a:schemeClr val="lt1"/>
+          </a:fontRef>
+        </p:style>
+        <p:txBody>
+          <a:bodyPr rtlCol="0" anchor="ctr"/>
+          <a:lstStyle/>
+          <a:p>
+            <a:pPr algn="ctr"/>
+          </a:p>
+        </p:txBody>
+      </p:sp>
+      <p:sp>
+        <p:nvSpPr>
+          <p:cNvPr id="6" name="TextBox 5"/>
+          <p:cNvSpPr txBox="1"/>
+          <p:nvPr/>
+        </p:nvSpPr>
+        <p:spPr>
+          <a:xfrm>
+            <a:off x="782920" y="3310000"/>
+            <a:ext cx="9625855" cy="360000"/>
+          </a:xfrm>
+          <a:prstGeom prst="rect">
+            <a:avLst/>
+          </a:prstGeom>
+          <a:noFill/>
+        </p:spPr>
+        <p:txBody>
+          <a:bodyPr wrap="square" anchor="t" lIns="0" rIns="0" tIns="0" bIns="0">
+            <a:spAutoFit/>
+          </a:bodyPr>
+          <a:lstStyle/>
+          <a:p>
+            <a:pPr algn="l"/>
+            <a:r>
+              <a:rPr sz="1500" b="1">
+                <a:solidFill>
+                  <a:srgbClr val="1A1A2E"/>
+                </a:solidFill>
+                <a:latin typeface="Segoe UI Semibold"/>
+              </a:rPr>
+              <a:t>The three components, in order</a:t>
+            </a:r>
+          </a:p>
+        </p:txBody>
+      </p:sp>
+      <p:sp>
+        <p:nvSpPr>
+          <p:cNvPr id="7" name="TextBox 6"/>
+          <p:cNvSpPr txBox="1"/>
+          <p:nvPr/>
+        </p:nvSpPr>
+        <p:spPr>
+          <a:xfrm>
+            <a:off x="782920" y="3710000"/>
+            <a:ext cx="9625855" cy="1500000"/>
+          </a:xfrm>
+          <a:prstGeom prst="rect">
+            <a:avLst/>
+          </a:prstGeom>
+          <a:noFill/>
+        </p:spPr>
+        <p:txBody>
+          <a:bodyPr wrap="square" anchor="t" lIns="0" rIns="0" tIns="0" bIns="0">
+            <a:spAutoFit/>
+          </a:bodyPr>
+          <a:lstStyle/>
+          <a:p>
+            <a:pPr algn="l">
+              <a:lnSpc>
+                <a:spcPct val="115000"/>
+              </a:lnSpc>
+            </a:pPr>
+            <a:r>
+              <a:rPr sz="1100" b="0">
+                <a:solidFill>
+                  <a:srgbClr val="6B6558"/>
+                </a:solidFill>
+                <a:latin typeface="Segoe UI"/>
+              </a:rPr>
+              <a:t/>
+            </a:r>
+          </a:p>
+        </p:txBody>
+      </p:sp>
+      <p:sp>
+        <p:nvSpPr>
+          <p:cNvPr id="8" name="Rounded Rectangle 7"/>
+          <p:cNvSpPr/>
+          <p:nvPr/>
+        </p:nvSpPr>
+        <p:spPr>
+          <a:xfrm>
+            <a:off x="10408775" y="3350000"/>
+            <a:ext cx="1000000" cy="280000"/>
+          </a:xfrm>
+          <a:prstGeom prst="roundRect">
+            <a:avLst>
+              <a:gd name="adj" fmla="val 50000"/>
+            </a:avLst>
+          </a:prstGeom>
+          <a:solidFill>
+            <a:srgbClr val="DDE9F7"/>
+          </a:solidFill>
+          <a:ln>
+            <a:noFill/>
+          </a:ln>
+          <a:effectLst/>
+        </p:spPr>
+        <p:style>
+          <a:lnRef idx="1">
+            <a:schemeClr val="accent1"/>
+          </a:lnRef>
+          <a:fillRef idx="3">
+            <a:schemeClr val="accent1"/>
+          </a:fillRef>
+          <a:effectRef idx="2">
+            <a:schemeClr val="accent1"/>
+          </a:effectRef>
+          <a:fontRef idx="minor">
+            <a:schemeClr val="lt1"/>
+          </a:fontRef>
+        </p:style>
+        <p:txBody>
+          <a:bodyPr rtlCol="0" anchor="ctr" lIns="60000" rIns="60000" tIns="0" bIns="0"/>
+          <a:lstStyle/>
+          <a:p>
+            <a:pPr algn="ctr"/>
+            <a:r>
+              <a:rPr sz="1000" b="1">
+                <a:solidFill>
+                  <a:srgbClr val="1C4E80"/>
+                </a:solidFill>
+                <a:latin typeface="Segoe UI Semibold"/>
+              </a:rPr>
+              <a:t>Measured</a:t>
+            </a:r>
+          </a:p>
+        </p:txBody>
+      </p:sp>
+      <p:sp>
+        <p:nvSpPr>
+          <p:cNvPr id="9" name="TextBox 8"/>
+          <p:cNvSpPr txBox="1"/>
+          <p:nvPr/>
+        </p:nvSpPr>
+        <p:spPr>
+          <a:xfrm>
+            <a:off x="782920" y="3750000"/>
+            <a:ext cx="4200000" cy="540000"/>
           </a:xfrm>
           <a:prstGeom prst="rect">
             <a:avLst/>
@@ -7316,21 +8884,21 @@
                 </a:solidFill>
                 <a:latin typeface="Segoe UI"/>
               </a:rPr>
-              <a:t>Find the real bottleneck: the shared amenities/filter step, not the DB fetch</a:t>
-            </a:r>
-          </a:p>
-        </p:txBody>
-      </p:sp>
-      <p:sp>
-        <p:nvSpPr>
-          <p:cNvPr id="9" name="TextBox 8"/>
-          <p:cNvSpPr txBox="1"/>
-          <p:nvPr/>
-        </p:nvSpPr>
-        <p:spPr>
-          <a:xfrm>
-            <a:off x="5102920" y="2160000"/>
-            <a:ext cx="6100000" cy="600000"/>
+              <a:t>WordPress nonce refresh (_getFreshNonce)</a:t>
+            </a:r>
+          </a:p>
+        </p:txBody>
+      </p:sp>
+      <p:sp>
+        <p:nvSpPr>
+          <p:cNvPr id="10" name="TextBox 9"/>
+          <p:cNvSpPr txBox="1"/>
+          <p:nvPr/>
+        </p:nvSpPr>
+        <p:spPr>
+          <a:xfrm>
+            <a:off x="5102920" y="3750000"/>
+            <a:ext cx="6100000" cy="540000"/>
           </a:xfrm>
           <a:prstGeom prst="rect">
             <a:avLst/>
@@ -7355,21 +8923,21 @@
                 </a:solidFill>
                 <a:latin typeface="Segoe UI Semibold"/>
               </a:rPr>
-              <a:t>Chunk time is 3.3–4.5s; today's fixes touch only ~350ms of that. The still-MySQL-sourced amenities query and filter/sort work dominate on both sides — that's where the next real win has to come from.</a:t>
-            </a:r>
-          </a:p>
-        </p:txBody>
-      </p:sp>
-      <p:sp>
-        <p:nvSpPr>
-          <p:cNvPr id="10" name="TextBox 9"/>
-          <p:cNvSpPr txBox="1"/>
-          <p:nvPr/>
-        </p:nvSpPr>
-        <p:spPr>
-          <a:xfrm>
-            <a:off x="782920" y="2760000"/>
-            <a:ext cx="4200000" cy="600000"/>
+              <a:t>8.4s  —  33.6% of total. A plain security-token round trip to admin-ajax.php — zero RateHawk or DB work, pure WP overhead, and it happens BEFORE the real search call is even allowed to fire.</a:t>
+            </a:r>
+          </a:p>
+        </p:txBody>
+      </p:sp>
+      <p:sp>
+        <p:nvSpPr>
+          <p:cNvPr id="11" name="TextBox 10"/>
+          <p:cNvSpPr txBox="1"/>
+          <p:nvPr/>
+        </p:nvSpPr>
+        <p:spPr>
+          <a:xfrm>
+            <a:off x="782920" y="4290000"/>
+            <a:ext cx="4200000" cy="540000"/>
           </a:xfrm>
           <a:prstGeom prst="rect">
             <a:avLst/>
@@ -7394,21 +8962,21 @@
                 </a:solidFill>
                 <a:latin typeface="Segoe UI"/>
               </a:rPr>
-              <a:t>Flag the today's-date plugin-directory incident to Hristijan</a:t>
-            </a:r>
-          </a:p>
-        </p:txBody>
-      </p:sp>
-      <p:sp>
-        <p:nvSpPr>
-          <p:cNvPr id="11" name="TextBox 10"/>
-          <p:cNvSpPr txBox="1"/>
-          <p:nvPr/>
-        </p:nvSpPr>
-        <p:spPr>
-          <a:xfrm>
-            <a:off x="5102920" y="2760000"/>
-            <a:ext cx="6100000" cy="600000"/>
+              <a:t>Live RateHawk fetch + Supabase/MySQL content assembly</a:t>
+            </a:r>
+          </a:p>
+        </p:txBody>
+      </p:sp>
+      <p:sp>
+        <p:nvSpPr>
+          <p:cNvPr id="12" name="TextBox 11"/>
+          <p:cNvSpPr txBox="1"/>
+          <p:nvPr/>
+        </p:nvSpPr>
+        <p:spPr>
+          <a:xfrm>
+            <a:off x="5102920" y="4290000"/>
+            <a:ext cx="6100000" cy="540000"/>
           </a:xfrm>
           <a:prstGeom prst="rect">
             <a:avLst/>
@@ -7433,21 +9001,21 @@
                 </a:solidFill>
                 <a:latin typeface="Segoe UI Semibold"/>
               </a:rPr>
-              <a:t>Something outside this session replaced wp-content/plugins/ today, wiping the fork's files — worth checking blast radius on other plugins</a:t>
-            </a:r>
-          </a:p>
-        </p:txBody>
-      </p:sp>
-      <p:sp>
-        <p:nvSpPr>
-          <p:cNvPr id="12" name="TextBox 11"/>
-          <p:cNvSpPr txBox="1"/>
-          <p:nvPr/>
-        </p:nvSpPr>
-        <p:spPr>
-          <a:xfrm>
-            <a:off x="782920" y="3360000"/>
-            <a:ext cx="4200000" cy="500000"/>
+              <a:t>16.3s  —  65.5% of total. The actual hotel search: live pricing round trip plus joining in static content (name, photos, address) for all matching hotels.</a:t>
+            </a:r>
+          </a:p>
+        </p:txBody>
+      </p:sp>
+      <p:sp>
+        <p:nvSpPr>
+          <p:cNvPr id="13" name="TextBox 12"/>
+          <p:cNvSpPr txBox="1"/>
+          <p:nvPr/>
+        </p:nvSpPr>
+        <p:spPr>
+          <a:xfrm>
+            <a:off x="782920" y="4830000"/>
+            <a:ext cx="4200000" cy="340000"/>
           </a:xfrm>
           <a:prstGeom prst="rect">
             <a:avLst/>
@@ -7472,21 +9040,21 @@
                 </a:solidFill>
                 <a:latin typeface="Segoe UI"/>
               </a:rPr>
-              <a:t>Real production page still renders blank</a:t>
-            </a:r>
-          </a:p>
-        </p:txBody>
-      </p:sp>
-      <p:sp>
-        <p:nvSpPr>
-          <p:cNvPr id="13" name="TextBox 12"/>
-          <p:cNvSpPr txBox="1"/>
-          <p:nvPr/>
-        </p:nvSpPr>
-        <p:spPr>
-          <a:xfrm>
-            <a:off x="5102920" y="3360000"/>
-            <a:ext cx="6100000" cy="500000"/>
+              <a:t>Client-side render (parse response, swap skeleton for real cards)</a:t>
+            </a:r>
+          </a:p>
+        </p:txBody>
+      </p:sp>
+      <p:sp>
+        <p:nvSpPr>
+          <p:cNvPr id="14" name="TextBox 13"/>
+          <p:cNvSpPr txBox="1"/>
+          <p:nvPr/>
+        </p:nvSpPr>
+        <p:spPr>
+          <a:xfrm>
+            <a:off x="5102920" y="4830000"/>
+            <a:ext cx="6100000" cy="340000"/>
           </a:xfrm>
           <a:prstGeom prst="rect">
             <a:avLst/>
@@ -7511,21 +9079,21 @@
                 </a:solidFill>
                 <a:latin typeface="Segoe UI Semibold"/>
               </a:rPr>
-              <a:t>Pre-existing, confirmed unrelated to this work — needs separate investigation on the tech team's side</a:t>
-            </a:r>
-          </a:p>
-        </p:txBody>
-      </p:sp>
-      <p:sp>
-        <p:nvSpPr>
-          <p:cNvPr id="14" name="TextBox 13"/>
-          <p:cNvSpPr txBox="1"/>
-          <p:nvPr/>
-        </p:nvSpPr>
-        <p:spPr>
-          <a:xfrm>
-            <a:off x="782920" y="3860000"/>
-            <a:ext cx="4200000" cy="340000"/>
+              <a:t>0.2s  —  0.9% of total. Effectively free — not a place to look for savings.</a:t>
+            </a:r>
+          </a:p>
+        </p:txBody>
+      </p:sp>
+      <p:sp>
+        <p:nvSpPr>
+          <p:cNvPr id="15" name="TextBox 14"/>
+          <p:cNvSpPr txBox="1"/>
+          <p:nvPr/>
+        </p:nvSpPr>
+        <p:spPr>
+          <a:xfrm>
+            <a:off x="502920" y="5580000"/>
+            <a:ext cx="11185855" cy="880000"/>
           </a:xfrm>
           <a:prstGeom prst="rect">
             <a:avLst/>
@@ -7540,31 +9108,280 @@
           <a:p>
             <a:pPr algn="l">
               <a:lnSpc>
-                <a:spcPct val="110000"/>
+                <a:spcPct val="115000"/>
               </a:lnSpc>
             </a:pPr>
             <a:r>
-              <a:rPr sz="1100" b="0">
-                <a:solidFill>
-                  <a:srgbClr val="6B6558"/>
+              <a:rPr sz="1000" b="0">
+                <a:solidFill>
+                  <a:srgbClr val="9B9384"/>
                 </a:solidFill>
                 <a:latin typeface="Segoe UI"/>
               </a:rPr>
-              <a:t>Engage Fable 5 on further user-facing speed options</a:t>
-            </a:r>
-          </a:p>
-        </p:txBody>
-      </p:sp>
-      <p:sp>
-        <p:nvSpPr>
-          <p:cNvPr id="15" name="TextBox 14"/>
-          <p:cNvSpPr txBox="1"/>
-          <p:nvPr/>
-        </p:nvSpPr>
-        <p:spPr>
-          <a:xfrm>
-            <a:off x="5102920" y="3860000"/>
-            <a:ext cx="6100000" cy="340000"/>
+              <a:t>Bug found while instrumenting this: the search FORM submits TWICE per single click (two independent “Form submitted” sequences from one click, confirmed via console log on synthetic and real OS-level clicks alike). Lives in production's shared hotel-search.js, not this fork. The fork's own generation-counter drops the stale duplicate, but the survivor sometimes then hit a hard client error (“Something went wrong”) instead of succeeding — seen after one plain click, 48s in. Doubles real RateHawk API call volume and server load per search either way.</a:t>
+            </a:r>
+          </a:p>
+        </p:txBody>
+      </p:sp>
+      <p:sp>
+        <p:nvSpPr>
+          <p:cNvPr id="16" name="TextBox 15"/>
+          <p:cNvSpPr txBox="1"/>
+          <p:nvPr/>
+        </p:nvSpPr>
+        <p:spPr>
+          <a:xfrm>
+            <a:off x="502920" y="6518000"/>
+            <a:ext cx="9000000" cy="240000"/>
+          </a:xfrm>
+          <a:prstGeom prst="rect">
+            <a:avLst/>
+          </a:prstGeom>
+          <a:noFill/>
+        </p:spPr>
+        <p:txBody>
+          <a:bodyPr wrap="square" anchor="t" lIns="0" rIns="0" tIns="0" bIns="0">
+            <a:spAutoFit/>
+          </a:bodyPr>
+          <a:lstStyle/>
+          <a:p>
+            <a:pPr algn="l"/>
+            <a:r>
+              <a:rPr sz="900" b="0">
+                <a:solidFill>
+                  <a:srgbClr val="9B9384"/>
+                </a:solidFill>
+                <a:latin typeface="Segoe UI"/>
+              </a:rPr>
+              <a:t>BALKANEA WEB  •  SUPABASE VS MYSQL COMPARISON</a:t>
+            </a:r>
+          </a:p>
+        </p:txBody>
+      </p:sp>
+      <p:sp>
+        <p:nvSpPr>
+          <p:cNvPr id="17" name="TextBox 16"/>
+          <p:cNvSpPr txBox="1"/>
+          <p:nvPr/>
+        </p:nvSpPr>
+        <p:spPr>
+          <a:xfrm>
+            <a:off x="11492000" y="6518000"/>
+            <a:ext cx="400000" cy="240000"/>
+          </a:xfrm>
+          <a:prstGeom prst="rect">
+            <a:avLst/>
+          </a:prstGeom>
+          <a:noFill/>
+        </p:spPr>
+        <p:txBody>
+          <a:bodyPr wrap="square" anchor="t" lIns="0" rIns="0" tIns="0" bIns="0">
+            <a:spAutoFit/>
+          </a:bodyPr>
+          <a:lstStyle/>
+          <a:p>
+            <a:pPr algn="r"/>
+            <a:r>
+              <a:rPr sz="900" b="0">
+                <a:solidFill>
+                  <a:srgbClr val="9B9384"/>
+                </a:solidFill>
+                <a:latin typeface="Segoe UI"/>
+              </a:rPr>
+              <a:t>8</a:t>
+            </a:r>
+          </a:p>
+        </p:txBody>
+      </p:sp>
+    </p:spTree>
+  </p:cSld>
+  <p:clrMapOvr>
+    <a:masterClrMapping/>
+  </p:clrMapOvr>
+</p:sld>
+</file>
+
+<file path=ppt/slides/slide9.xml><?xml version="1.0" encoding="utf-8"?>
+<p:sld xmlns:a="http://schemas.openxmlformats.org/drawingml/2006/main" xmlns:p="http://schemas.openxmlformats.org/presentationml/2006/main" xmlns:r="http://schemas.openxmlformats.org/officeDocument/2006/relationships">
+  <p:cSld>
+    <p:bg>
+      <p:bgPr>
+        <a:solidFill>
+          <a:srgbClr val="FAF7F2"/>
+        </a:solidFill>
+        <a:effectLst/>
+      </p:bgPr>
+    </p:bg>
+    <p:spTree>
+      <p:nvGrpSpPr>
+        <p:cNvPr id="1" name=""/>
+        <p:cNvGrpSpPr/>
+        <p:nvPr/>
+      </p:nvGrpSpPr>
+      <p:grpSpPr/>
+      <p:sp>
+        <p:nvSpPr>
+          <p:cNvPr id="2" name="TextBox 1"/>
+          <p:cNvSpPr txBox="1"/>
+          <p:nvPr/>
+        </p:nvSpPr>
+        <p:spPr>
+          <a:xfrm>
+            <a:off x="502920" y="560000"/>
+            <a:ext cx="11185855" cy="300000"/>
+          </a:xfrm>
+          <a:prstGeom prst="rect">
+            <a:avLst/>
+          </a:prstGeom>
+          <a:noFill/>
+        </p:spPr>
+        <p:txBody>
+          <a:bodyPr wrap="square" anchor="t" lIns="0" rIns="0" tIns="0" bIns="0">
+            <a:spAutoFit/>
+          </a:bodyPr>
+          <a:lstStyle/>
+          <a:p>
+            <a:pPr algn="l"/>
+            <a:r>
+              <a:rPr sz="1300" b="1">
+                <a:solidFill>
+                  <a:srgbClr val="7A3E0F"/>
+                </a:solidFill>
+                <a:latin typeface="Segoe UI Semibold"/>
+              </a:rPr>
+              <a:t>08  —  HOW TO MAKE IT FASTER</a:t>
+            </a:r>
+          </a:p>
+        </p:txBody>
+      </p:sp>
+      <p:sp>
+        <p:nvSpPr>
+          <p:cNvPr id="3" name="TextBox 2"/>
+          <p:cNvSpPr txBox="1"/>
+          <p:nvPr/>
+        </p:nvSpPr>
+        <p:spPr>
+          <a:xfrm>
+            <a:off x="502920" y="880000"/>
+            <a:ext cx="11185855" cy="500000"/>
+          </a:xfrm>
+          <a:prstGeom prst="rect">
+            <a:avLst/>
+          </a:prstGeom>
+          <a:noFill/>
+        </p:spPr>
+        <p:txBody>
+          <a:bodyPr wrap="square" anchor="t" lIns="0" rIns="0" tIns="0" bIns="0">
+            <a:spAutoFit/>
+          </a:bodyPr>
+          <a:lstStyle/>
+          <a:p>
+            <a:pPr algn="l"/>
+            <a:r>
+              <a:rPr sz="2400" b="1">
+                <a:solidFill>
+                  <a:srgbClr val="1A1A2E"/>
+                </a:solidFill>
+                <a:latin typeface="Segoe UI Semibold"/>
+              </a:rPr>
+              <a:t>One ranked list — by measured impact, biggest first</a:t>
+            </a:r>
+          </a:p>
+        </p:txBody>
+      </p:sp>
+      <p:sp>
+        <p:nvSpPr>
+          <p:cNvPr id="4" name="Rounded Rectangle 3"/>
+          <p:cNvSpPr/>
+          <p:nvPr/>
+        </p:nvSpPr>
+        <p:spPr>
+          <a:xfrm>
+            <a:off x="502920" y="1560000"/>
+            <a:ext cx="11185855" cy="1650000"/>
+          </a:xfrm>
+          <a:prstGeom prst="roundRect">
+            <a:avLst>
+              <a:gd name="adj" fmla="val 3500"/>
+            </a:avLst>
+          </a:prstGeom>
+          <a:solidFill>
+            <a:srgbClr val="FFFFFF"/>
+          </a:solidFill>
+          <a:ln w="9525">
+            <a:solidFill>
+              <a:srgbClr val="ECE6DC"/>
+            </a:solidFill>
+          </a:ln>
+          <a:effectLst/>
+        </p:spPr>
+        <p:style>
+          <a:lnRef idx="1">
+            <a:schemeClr val="accent1"/>
+          </a:lnRef>
+          <a:fillRef idx="3">
+            <a:schemeClr val="accent1"/>
+          </a:fillRef>
+          <a:effectRef idx="2">
+            <a:schemeClr val="accent1"/>
+          </a:effectRef>
+          <a:fontRef idx="minor">
+            <a:schemeClr val="lt1"/>
+          </a:fontRef>
+        </p:style>
+        <p:txBody>
+          <a:bodyPr rtlCol="0" anchor="ctr"/>
+          <a:lstStyle/>
+          <a:p>
+            <a:pPr algn="ctr"/>
+          </a:p>
+        </p:txBody>
+      </p:sp>
+      <p:sp>
+        <p:nvSpPr>
+          <p:cNvPr id="5" name="TextBox 4"/>
+          <p:cNvSpPr txBox="1"/>
+          <p:nvPr/>
+        </p:nvSpPr>
+        <p:spPr>
+          <a:xfrm>
+            <a:off x="782920" y="1720000"/>
+            <a:ext cx="9625855" cy="360000"/>
+          </a:xfrm>
+          <a:prstGeom prst="rect">
+            <a:avLst/>
+          </a:prstGeom>
+          <a:noFill/>
+        </p:spPr>
+        <p:txBody>
+          <a:bodyPr wrap="square" anchor="t" lIns="0" rIns="0" tIns="0" bIns="0">
+            <a:spAutoFit/>
+          </a:bodyPr>
+          <a:lstStyle/>
+          <a:p>
+            <a:pPr algn="l"/>
+            <a:r>
+              <a:rPr sz="1500" b="1">
+                <a:solidFill>
+                  <a:srgbClr val="1A1A2E"/>
+                </a:solidFill>
+                <a:latin typeface="Segoe UI Semibold"/>
+              </a:rPr>
+              <a:t>#1 — Stop the repeating/duplicate admin-ajax loop</a:t>
+            </a:r>
+          </a:p>
+        </p:txBody>
+      </p:sp>
+      <p:sp>
+        <p:nvSpPr>
+          <p:cNvPr id="6" name="TextBox 5"/>
+          <p:cNvSpPr txBox="1"/>
+          <p:nvPr/>
+        </p:nvSpPr>
+        <p:spPr>
+          <a:xfrm>
+            <a:off x="782920" y="2120000"/>
+            <a:ext cx="9625855" cy="950000"/>
           </a:xfrm>
           <a:prstGeom prst="rect">
             <a:avLst/>
@@ -7579,17 +9396,426 @@
           <a:p>
             <a:pPr algn="l">
               <a:lnSpc>
-                <a:spcPct val="110000"/>
+                <a:spcPct val="115000"/>
               </a:lnSpc>
             </a:pPr>
             <a:r>
-              <a:rPr sz="1100" b="1">
+              <a:rPr sz="1100" b="0">
+                <a:solidFill>
+                  <a:srgbClr val="6B6558"/>
+                </a:solidFill>
+                <a:latin typeface="Segoe UI"/>
+              </a:rPr>
+              <a:t>Biggest lever by far. Confirmed today on BOTH sides: literal concurrent duplicate chunk requests, plus a polling loop that keeps firing every ~4s well past when results stop growing. This alone is most of the gap between today's 67–122s totals and 9/14's 14–18s baseline — and it's why Supabase shows ~2x the hotel count MySQL does for the same query (duplicated chunks, not real inventory). Fix: the same dedup/stale-response guard Fix 2 already added for the click path, plus stop the loop on the real terminal chunk (hasMore:false) instead of retrying.</a:t>
+            </a:r>
+          </a:p>
+        </p:txBody>
+      </p:sp>
+      <p:sp>
+        <p:nvSpPr>
+          <p:cNvPr id="7" name="Rounded Rectangle 6"/>
+          <p:cNvSpPr/>
+          <p:nvPr/>
+        </p:nvSpPr>
+        <p:spPr>
+          <a:xfrm>
+            <a:off x="10408775" y="1760000"/>
+            <a:ext cx="1000000" cy="280000"/>
+          </a:xfrm>
+          <a:prstGeom prst="roundRect">
+            <a:avLst>
+              <a:gd name="adj" fmla="val 50000"/>
+            </a:avLst>
+          </a:prstGeom>
+          <a:solidFill>
+            <a:srgbClr val="E1EFE6"/>
+          </a:solidFill>
+          <a:ln>
+            <a:noFill/>
+          </a:ln>
+          <a:effectLst/>
+        </p:spPr>
+        <p:style>
+          <a:lnRef idx="1">
+            <a:schemeClr val="accent1"/>
+          </a:lnRef>
+          <a:fillRef idx="3">
+            <a:schemeClr val="accent1"/>
+          </a:fillRef>
+          <a:effectRef idx="2">
+            <a:schemeClr val="accent1"/>
+          </a:effectRef>
+          <a:fontRef idx="minor">
+            <a:schemeClr val="lt1"/>
+          </a:fontRef>
+        </p:style>
+        <p:txBody>
+          <a:bodyPr rtlCol="0" anchor="ctr" lIns="60000" rIns="60000" tIns="0" bIns="0"/>
+          <a:lstStyle/>
+          <a:p>
+            <a:pPr algn="ctr"/>
+            <a:r>
+              <a:rPr sz="1000" b="1">
+                <a:solidFill>
+                  <a:srgbClr val="1F7A4D"/>
+                </a:solidFill>
+                <a:latin typeface="Segoe UI Semibold"/>
+              </a:rPr>
+              <a:t>Backend</a:t>
+            </a:r>
+          </a:p>
+        </p:txBody>
+      </p:sp>
+      <p:sp>
+        <p:nvSpPr>
+          <p:cNvPr id="8" name="Rounded Rectangle 7"/>
+          <p:cNvSpPr/>
+          <p:nvPr/>
+        </p:nvSpPr>
+        <p:spPr>
+          <a:xfrm>
+            <a:off x="502920" y="3360000"/>
+            <a:ext cx="11185855" cy="1200000"/>
+          </a:xfrm>
+          <a:prstGeom prst="roundRect">
+            <a:avLst>
+              <a:gd name="adj" fmla="val 3500"/>
+            </a:avLst>
+          </a:prstGeom>
+          <a:solidFill>
+            <a:srgbClr val="FFFFFF"/>
+          </a:solidFill>
+          <a:ln w="9525">
+            <a:solidFill>
+              <a:srgbClr val="ECE6DC"/>
+            </a:solidFill>
+          </a:ln>
+          <a:effectLst/>
+        </p:spPr>
+        <p:style>
+          <a:lnRef idx="1">
+            <a:schemeClr val="accent1"/>
+          </a:lnRef>
+          <a:fillRef idx="3">
+            <a:schemeClr val="accent1"/>
+          </a:fillRef>
+          <a:effectRef idx="2">
+            <a:schemeClr val="accent1"/>
+          </a:effectRef>
+          <a:fontRef idx="minor">
+            <a:schemeClr val="lt1"/>
+          </a:fontRef>
+        </p:style>
+        <p:txBody>
+          <a:bodyPr rtlCol="0" anchor="ctr"/>
+          <a:lstStyle/>
+          <a:p>
+            <a:pPr algn="ctr"/>
+          </a:p>
+        </p:txBody>
+      </p:sp>
+      <p:sp>
+        <p:nvSpPr>
+          <p:cNvPr id="9" name="TextBox 8"/>
+          <p:cNvSpPr txBox="1"/>
+          <p:nvPr/>
+        </p:nvSpPr>
+        <p:spPr>
+          <a:xfrm>
+            <a:off x="782920" y="3520000"/>
+            <a:ext cx="9625855" cy="360000"/>
+          </a:xfrm>
+          <a:prstGeom prst="rect">
+            <a:avLst/>
+          </a:prstGeom>
+          <a:noFill/>
+        </p:spPr>
+        <p:txBody>
+          <a:bodyPr wrap="square" anchor="t" lIns="0" rIns="0" tIns="0" bIns="0">
+            <a:spAutoFit/>
+          </a:bodyPr>
+          <a:lstStyle/>
+          <a:p>
+            <a:pPr algn="l"/>
+            <a:r>
+              <a:rPr sz="1500" b="1">
                 <a:solidFill>
                   <a:srgbClr val="1A1A2E"/>
                 </a:solidFill>
                 <a:latin typeface="Segoe UI Semibold"/>
               </a:rPr>
-              <a:t>Beyond today's Tier-1 DB fixes — exploring what else moves the needle on perceived load time, in progress</a:t>
+              <a:t>#2 — Batch or parallelize chunk fetches instead of one every ~4s</a:t>
+            </a:r>
+          </a:p>
+        </p:txBody>
+      </p:sp>
+      <p:sp>
+        <p:nvSpPr>
+          <p:cNvPr id="10" name="TextBox 9"/>
+          <p:cNvSpPr txBox="1"/>
+          <p:nvPr/>
+        </p:nvSpPr>
+        <p:spPr>
+          <a:xfrm>
+            <a:off x="782920" y="3920000"/>
+            <a:ext cx="9625855" cy="500000"/>
+          </a:xfrm>
+          <a:prstGeom prst="rect">
+            <a:avLst/>
+          </a:prstGeom>
+          <a:noFill/>
+        </p:spPr>
+        <p:txBody>
+          <a:bodyPr wrap="square" anchor="t" lIns="0" rIns="0" tIns="0" bIns="0">
+            <a:spAutoFit/>
+          </a:bodyPr>
+          <a:lstStyle/>
+          <a:p>
+            <a:pPr algn="l">
+              <a:lnSpc>
+                <a:spcPct val="115000"/>
+              </a:lnSpc>
+            </a:pPr>
+            <a:r>
+              <a:rPr sz="1100" b="0">
+                <a:solidFill>
+                  <a:srgbClr val="6B6558"/>
+                </a:solidFill>
+                <a:latin typeface="Segoe UI"/>
+              </a:rPr>
+              <a:t>Total time now scales almost linearly with hotel count (17–19 calls for MySQL, 26–29 for Supabase) because chunks fetch one at a time with a fixed pacing gap between them. Fetching 2–3 chunks concurrently would cut total time roughly in proportion, on top of the #1 fix.</a:t>
+            </a:r>
+          </a:p>
+        </p:txBody>
+      </p:sp>
+      <p:sp>
+        <p:nvSpPr>
+          <p:cNvPr id="11" name="Rounded Rectangle 10"/>
+          <p:cNvSpPr/>
+          <p:nvPr/>
+        </p:nvSpPr>
+        <p:spPr>
+          <a:xfrm>
+            <a:off x="10408775" y="3560000"/>
+            <a:ext cx="1000000" cy="280000"/>
+          </a:xfrm>
+          <a:prstGeom prst="roundRect">
+            <a:avLst>
+              <a:gd name="adj" fmla="val 50000"/>
+            </a:avLst>
+          </a:prstGeom>
+          <a:solidFill>
+            <a:srgbClr val="E1EFE6"/>
+          </a:solidFill>
+          <a:ln>
+            <a:noFill/>
+          </a:ln>
+          <a:effectLst/>
+        </p:spPr>
+        <p:style>
+          <a:lnRef idx="1">
+            <a:schemeClr val="accent1"/>
+          </a:lnRef>
+          <a:fillRef idx="3">
+            <a:schemeClr val="accent1"/>
+          </a:fillRef>
+          <a:effectRef idx="2">
+            <a:schemeClr val="accent1"/>
+          </a:effectRef>
+          <a:fontRef idx="minor">
+            <a:schemeClr val="lt1"/>
+          </a:fontRef>
+        </p:style>
+        <p:txBody>
+          <a:bodyPr rtlCol="0" anchor="ctr" lIns="60000" rIns="60000" tIns="0" bIns="0"/>
+          <a:lstStyle/>
+          <a:p>
+            <a:pPr algn="ctr"/>
+            <a:r>
+              <a:rPr sz="1000" b="1">
+                <a:solidFill>
+                  <a:srgbClr val="1F7A4D"/>
+                </a:solidFill>
+                <a:latin typeface="Segoe UI Semibold"/>
+              </a:rPr>
+              <a:t>Backend</a:t>
+            </a:r>
+          </a:p>
+        </p:txBody>
+      </p:sp>
+      <p:sp>
+        <p:nvSpPr>
+          <p:cNvPr id="12" name="Rounded Rectangle 11"/>
+          <p:cNvSpPr/>
+          <p:nvPr/>
+        </p:nvSpPr>
+        <p:spPr>
+          <a:xfrm>
+            <a:off x="502920" y="4710000"/>
+            <a:ext cx="11185855" cy="1200000"/>
+          </a:xfrm>
+          <a:prstGeom prst="roundRect">
+            <a:avLst>
+              <a:gd name="adj" fmla="val 3500"/>
+            </a:avLst>
+          </a:prstGeom>
+          <a:solidFill>
+            <a:srgbClr val="FFFFFF"/>
+          </a:solidFill>
+          <a:ln w="9525">
+            <a:solidFill>
+              <a:srgbClr val="ECE6DC"/>
+            </a:solidFill>
+          </a:ln>
+          <a:effectLst/>
+        </p:spPr>
+        <p:style>
+          <a:lnRef idx="1">
+            <a:schemeClr val="accent1"/>
+          </a:lnRef>
+          <a:fillRef idx="3">
+            <a:schemeClr val="accent1"/>
+          </a:fillRef>
+          <a:effectRef idx="2">
+            <a:schemeClr val="accent1"/>
+          </a:effectRef>
+          <a:fontRef idx="minor">
+            <a:schemeClr val="lt1"/>
+          </a:fontRef>
+        </p:style>
+        <p:txBody>
+          <a:bodyPr rtlCol="0" anchor="ctr"/>
+          <a:lstStyle/>
+          <a:p>
+            <a:pPr algn="ctr"/>
+          </a:p>
+        </p:txBody>
+      </p:sp>
+      <p:sp>
+        <p:nvSpPr>
+          <p:cNvPr id="13" name="TextBox 12"/>
+          <p:cNvSpPr txBox="1"/>
+          <p:nvPr/>
+        </p:nvSpPr>
+        <p:spPr>
+          <a:xfrm>
+            <a:off x="782920" y="4870000"/>
+            <a:ext cx="9625855" cy="360000"/>
+          </a:xfrm>
+          <a:prstGeom prst="rect">
+            <a:avLst/>
+          </a:prstGeom>
+          <a:noFill/>
+        </p:spPr>
+        <p:txBody>
+          <a:bodyPr wrap="square" anchor="t" lIns="0" rIns="0" tIns="0" bIns="0">
+            <a:spAutoFit/>
+          </a:bodyPr>
+          <a:lstStyle/>
+          <a:p>
+            <a:pPr algn="l"/>
+            <a:r>
+              <a:rPr sz="1500" b="1">
+                <a:solidFill>
+                  <a:srgbClr val="1A1A2E"/>
+                </a:solidFill>
+                <a:latin typeface="Segoe UI Semibold"/>
+              </a:rPr>
+              <a:t>#3 — Take the WordPress nonce refresh off the critical path</a:t>
+            </a:r>
+          </a:p>
+        </p:txBody>
+      </p:sp>
+      <p:sp>
+        <p:nvSpPr>
+          <p:cNvPr id="14" name="TextBox 13"/>
+          <p:cNvSpPr txBox="1"/>
+          <p:nvPr/>
+        </p:nvSpPr>
+        <p:spPr>
+          <a:xfrm>
+            <a:off x="782920" y="5270000"/>
+            <a:ext cx="9625855" cy="500000"/>
+          </a:xfrm>
+          <a:prstGeom prst="rect">
+            <a:avLst/>
+          </a:prstGeom>
+          <a:noFill/>
+        </p:spPr>
+        <p:txBody>
+          <a:bodyPr wrap="square" anchor="t" lIns="0" rIns="0" tIns="0" bIns="0">
+            <a:spAutoFit/>
+          </a:bodyPr>
+          <a:lstStyle/>
+          <a:p>
+            <a:pPr algn="l">
+              <a:lnSpc>
+                <a:spcPct val="115000"/>
+              </a:lnSpc>
+            </a:pPr>
+            <a:r>
+              <a:rPr sz="1100" b="0">
+                <a:solidFill>
+                  <a:srgbClr val="6B6558"/>
+                </a:solidFill>
+                <a:latin typeface="Segoe UI"/>
+              </a:rPr>
+              <a:t>Still a fixed ~8.4s tax (33.6% of the original 24.8s search) on every search before either fix above even starts — pre-fetch it on page load, before Search is clicked. Smaller than #1/#2 today, but free once they're done.</a:t>
+            </a:r>
+          </a:p>
+        </p:txBody>
+      </p:sp>
+      <p:sp>
+        <p:nvSpPr>
+          <p:cNvPr id="15" name="Rounded Rectangle 14"/>
+          <p:cNvSpPr/>
+          <p:nvPr/>
+        </p:nvSpPr>
+        <p:spPr>
+          <a:xfrm>
+            <a:off x="10408775" y="4910000"/>
+            <a:ext cx="1000000" cy="280000"/>
+          </a:xfrm>
+          <a:prstGeom prst="roundRect">
+            <a:avLst>
+              <a:gd name="adj" fmla="val 50000"/>
+            </a:avLst>
+          </a:prstGeom>
+          <a:solidFill>
+            <a:srgbClr val="E1EFE6"/>
+          </a:solidFill>
+          <a:ln>
+            <a:noFill/>
+          </a:ln>
+          <a:effectLst/>
+        </p:spPr>
+        <p:style>
+          <a:lnRef idx="1">
+            <a:schemeClr val="accent1"/>
+          </a:lnRef>
+          <a:fillRef idx="3">
+            <a:schemeClr val="accent1"/>
+          </a:fillRef>
+          <a:effectRef idx="2">
+            <a:schemeClr val="accent1"/>
+          </a:effectRef>
+          <a:fontRef idx="minor">
+            <a:schemeClr val="lt1"/>
+          </a:fontRef>
+        </p:style>
+        <p:txBody>
+          <a:bodyPr rtlCol="0" anchor="ctr" lIns="60000" rIns="60000" tIns="0" bIns="0"/>
+          <a:lstStyle/>
+          <a:p>
+            <a:pPr algn="ctr"/>
+            <a:r>
+              <a:rPr sz="1000" b="1">
+                <a:solidFill>
+                  <a:srgbClr val="1F7A4D"/>
+                </a:solidFill>
+                <a:latin typeface="Segoe UI Semibold"/>
+              </a:rPr>
+              <a:t>Backend</a:t>
             </a:r>
           </a:p>
         </p:txBody>
@@ -7659,7 +9885,7 @@
                 </a:solidFill>
                 <a:latin typeface="Segoe UI"/>
               </a:rPr>
-              <a:t>7</a:t>
+              <a:t>9</a:t>
             </a:r>
           </a:p>
         </p:txBody>

</xml_diff>